<commit_message>
Complete step-by-step visual guides for Lab 06
</commit_message>
<xml_diff>
--- a/slides/LAB06_Cloud_Notes_Compose_Bukti_Live.pptx
+++ b/slides/LAB06_Cloud_Notes_Compose_Bukti_Live.pptx
@@ -22,6 +22,9 @@
     <p:sldId id="299" r:id="rId13"/>
     <p:sldId id="300" r:id="rId14"/>
     <p:sldId id="301" r:id="rId15"/>
+    <p:sldId id="302" r:id="rId21"/>
+    <p:sldId id="303" r:id="rId22"/>
+    <p:sldId id="304" r:id="rId23"/>
   </p:sldIdLst>
   <p:sldSz cx="12192000" cy="6858000"/>
   <p:notesSz cx="6858000" cy="12192000"/>
@@ -6250,6 +6253,1974 @@
         <p14:creationId xmlns:p14="http://schemas.microsoft.com/office/powerpoint/2010/main" val="3583953677"/>
       </p:ext>
     </p:extLst>
+  </p:cSld>
+  <p:clrMapOvr>
+    <a:masterClrMapping/>
+  </p:clrMapOvr>
+</p:sld>
+</file>
+
+<file path=ppt/slides/slide15.xml><?xml version="1.0" encoding="utf-8"?>
+<p:sld xmlns:a="http://schemas.openxmlformats.org/drawingml/2006/main" xmlns:p="http://schemas.openxmlformats.org/presentationml/2006/main" xmlns:r="http://schemas.openxmlformats.org/officeDocument/2006/relationships">
+  <p:cSld>
+    <p:spTree>
+      <p:nvGrpSpPr>
+        <p:cNvPr id="1" name=""/>
+        <p:cNvGrpSpPr/>
+        <p:nvPr/>
+      </p:nvGrpSpPr>
+      <p:grpSpPr/>
+      <p:sp>
+        <p:nvSpPr>
+          <p:cNvPr id="2" name="Text 0"/>
+          <p:cNvSpPr/>
+          <p:nvPr/>
+        </p:nvSpPr>
+        <p:spPr>
+          <a:xfrm>
+            <a:off x="457200" y="6492240"/>
+            <a:ext cx="7315200" cy="274320"/>
+          </a:xfrm>
+          <a:prstGeom prst="rect">
+            <a:avLst/>
+          </a:prstGeom>
+          <a:noFill/>
+          <a:ln/>
+        </p:spPr>
+        <p:txBody>
+          <a:bodyPr wrap="square" lIns="0" tIns="0" rIns="0" bIns="0" rtlCol="0" anchor="ctr"/>
+          <a:lstStyle/>
+          <a:p>
+            <a:pPr marL="0" indent="0" algn="l">
+              <a:buNone/>
+            </a:pPr>
+            <a:r>
+              <a:rPr lang="en-US" sz="900" dirty="0">
+                <a:solidFill>
+                  <a:srgbClr val="64748B"/>
+                </a:solidFill>
+                <a:latin typeface="Calibri" pitchFamily="34" charset="0"/>
+                <a:ea typeface="Calibri" pitchFamily="34" charset="-122"/>
+                <a:cs typeface="Calibri" pitchFamily="34" charset="-120"/>
+              </a:rPr>
+              <a:t>BINUS UNIVERSITY  |  Cloud Services  |  Praktikum 6</a:t>
+            </a:r>
+            <a:endParaRPr lang="en-US" sz="900" dirty="0"/>
+          </a:p>
+        </p:txBody>
+      </p:sp>
+      <p:sp>
+        <p:nvSpPr>
+          <p:cNvPr id="3" name="Text 1"/>
+          <p:cNvSpPr/>
+          <p:nvPr/>
+        </p:nvSpPr>
+        <p:spPr>
+          <a:xfrm>
+            <a:off x="11247120" y="6492240"/>
+            <a:ext cx="457200" cy="274320"/>
+          </a:xfrm>
+          <a:prstGeom prst="rect">
+            <a:avLst/>
+          </a:prstGeom>
+          <a:noFill/>
+          <a:ln/>
+        </p:spPr>
+        <p:txBody>
+          <a:bodyPr wrap="square" lIns="0" tIns="0" rIns="0" bIns="0" rtlCol="0" anchor="ctr"/>
+          <a:lstStyle/>
+          <a:p>
+            <a:pPr marL="0" indent="0" algn="r">
+              <a:buNone/>
+            </a:pPr>
+            <a:r>
+              <a:rPr lang="en-US" sz="900" b="1">
+                <a:solidFill>
+                  <a:srgbClr val="64748B"/>
+                </a:solidFill>
+                <a:latin typeface="Calibri" pitchFamily="34" charset="0"/>
+                <a:ea typeface="Calibri" pitchFamily="34" charset="-122"/>
+                <a:cs typeface="Calibri" pitchFamily="34" charset="-120"/>
+              </a:rPr>
+              <a:t>15</a:t>
+            </a:r>
+            <a:endParaRPr lang="en-US" sz="900" dirty="0"/>
+          </a:p>
+        </p:txBody>
+      </p:sp>
+      <p:sp>
+        <p:nvSpPr>
+          <p:cNvPr id="4" name="Shape 2"/>
+          <p:cNvSpPr/>
+          <p:nvPr/>
+        </p:nvSpPr>
+        <p:spPr>
+          <a:xfrm>
+            <a:off x="457200" y="6446520"/>
+            <a:ext cx="228600" cy="36576"/>
+          </a:xfrm>
+          <a:prstGeom prst="rect">
+            <a:avLst/>
+          </a:prstGeom>
+          <a:solidFill>
+            <a:srgbClr val="F37021"/>
+          </a:solidFill>
+          <a:ln w="12700">
+            <a:solidFill>
+              <a:srgbClr val="F37021"/>
+            </a:solidFill>
+            <a:prstDash val="solid"/>
+          </a:ln>
+        </p:spPr>
+      </p:sp>
+      <p:pic>
+        <p:nvPicPr>
+          <p:cNvPr id="5" name="Picture 4" descr="image.png"/>
+          <p:cNvPicPr>
+            <a:picLocks noChangeAspect="1"/>
+          </p:cNvPicPr>
+          <p:nvPr/>
+        </p:nvPicPr>
+        <p:blipFill>
+          <a:blip r:embed="rId2"/>
+          <a:stretch>
+            <a:fillRect/>
+          </a:stretch>
+        </p:blipFill>
+        <p:spPr>
+          <a:xfrm>
+            <a:off x="274320" y="164592"/>
+            <a:ext cx="914400" cy="603504"/>
+          </a:xfrm>
+          <a:prstGeom prst="rect">
+            <a:avLst/>
+          </a:prstGeom>
+        </p:spPr>
+      </p:pic>
+      <p:pic>
+        <p:nvPicPr>
+          <p:cNvPr id="6" name="Picture 5" descr="image.png"/>
+          <p:cNvPicPr>
+            <a:picLocks noChangeAspect="1"/>
+          </p:cNvPicPr>
+          <p:nvPr/>
+        </p:nvPicPr>
+        <p:blipFill>
+          <a:blip r:embed="rId3"/>
+          <a:stretch>
+            <a:fillRect/>
+          </a:stretch>
+        </p:blipFill>
+        <p:spPr>
+          <a:xfrm>
+            <a:off x="10881360" y="182880"/>
+            <a:ext cx="1005840" cy="512064"/>
+          </a:xfrm>
+          <a:prstGeom prst="rect">
+            <a:avLst/>
+          </a:prstGeom>
+        </p:spPr>
+      </p:pic>
+      <p:sp>
+        <p:nvSpPr>
+          <p:cNvPr id="7" name="Shape 3"/>
+          <p:cNvSpPr/>
+          <p:nvPr/>
+        </p:nvSpPr>
+        <p:spPr>
+          <a:xfrm>
+            <a:off x="457200" y="868680"/>
+            <a:ext cx="11247120" cy="0"/>
+          </a:xfrm>
+          <a:prstGeom prst="line">
+            <a:avLst/>
+          </a:prstGeom>
+          <a:noFill/>
+          <a:ln w="12700">
+            <a:solidFill>
+              <a:srgbClr val="E2E8F0"/>
+            </a:solidFill>
+            <a:prstDash val="solid"/>
+          </a:ln>
+        </p:spPr>
+      </p:sp>
+      <p:sp>
+        <p:nvSpPr>
+          <p:cNvPr id="8" name="Text 4"/>
+          <p:cNvSpPr/>
+          <p:nvPr/>
+        </p:nvSpPr>
+        <p:spPr>
+          <a:xfrm>
+            <a:off x="2011680" y="182880"/>
+            <a:ext cx="8138160" cy="502920"/>
+          </a:xfrm>
+          <a:prstGeom prst="rect">
+            <a:avLst/>
+          </a:prstGeom>
+          <a:noFill/>
+          <a:ln/>
+        </p:spPr>
+        <p:txBody>
+          <a:bodyPr wrap="square" lIns="0" tIns="0" rIns="0" bIns="0" rtlCol="0" anchor="ctr"/>
+          <a:lstStyle/>
+          <a:p>
+            <a:pPr marL="0" indent="0" algn="ctr">
+              <a:buNone/>
+            </a:pPr>
+            <a:r>
+              <a:rPr lang="nl-NL" sz="2200" b="1">
+                <a:solidFill>
+                  <a:srgbClr val="1976D2"/>
+                </a:solidFill>
+                <a:latin typeface="Calibri" pitchFamily="34" charset="0"/>
+                <a:ea typeface="Calibri" pitchFamily="34" charset="-122"/>
+                <a:cs typeface="Calibri" pitchFamily="34" charset="-120"/>
+              </a:rPr>
+              <a:t>Bukti awal | secret dan config</a:t>
+            </a:r>
+            <a:endParaRPr lang="en-US" sz="2200" dirty="0"/>
+          </a:p>
+        </p:txBody>
+      </p:sp>
+      <p:sp>
+        <p:nvSpPr>
+          <p:cNvPr id="9" name="Text 5"/>
+          <p:cNvSpPr/>
+          <p:nvPr/>
+        </p:nvSpPr>
+        <p:spPr>
+          <a:xfrm>
+            <a:off x="457200" y="960120"/>
+            <a:ext cx="11247120" cy="320040"/>
+          </a:xfrm>
+          <a:prstGeom prst="rect">
+            <a:avLst/>
+          </a:prstGeom>
+          <a:noFill/>
+          <a:ln/>
+        </p:spPr>
+        <p:txBody>
+          <a:bodyPr wrap="square" lIns="0" tIns="0" rIns="0" bIns="0" rtlCol="0" anchor="ctr"/>
+          <a:lstStyle/>
+          <a:p>
+            <a:pPr marL="0" indent="0" algn="ctr">
+              <a:buNone/>
+            </a:pPr>
+            <a:r>
+              <a:rPr lang="en-US" sz="1200" i="1">
+                <a:solidFill>
+                  <a:srgbClr val="64748B"/>
+                </a:solidFill>
+                <a:latin typeface="Calibri" pitchFamily="34" charset="0"/>
+                <a:ea typeface="Calibri" pitchFamily="34" charset="-122"/>
+                <a:cs typeface="Calibri" pitchFamily="34" charset="-120"/>
+              </a:rPr>
+              <a:t>Test-Path; compose config; check-ignore  |  tanpa isi password</a:t>
+            </a:r>
+            <a:endParaRPr lang="en-US" sz="1200" dirty="0"/>
+          </a:p>
+        </p:txBody>
+      </p:sp>
+      <p:sp>
+        <p:nvSpPr>
+          <p:cNvPr id="27" name="Rectangle 26">
+            <a:extLst>
+              <a:ext uri="{FF2B5EF4-FFF2-40B4-BE49-F238E27FC236}">
+                <a16:creationId xmlns:a16="http://schemas.microsoft.com/office/drawing/2014/main" id="{CA2C3FC3-2268-3632-60A5-8F36FCCD90BB}"/>
+              </a:ext>
+            </a:extLst>
+          </p:cNvPr>
+          <p:cNvSpPr/>
+          <p:nvPr/>
+        </p:nvSpPr>
+        <p:spPr>
+          <a:xfrm>
+            <a:off x="457200" y="1409700"/>
+            <a:ext cx="11252200" cy="3886200"/>
+          </a:xfrm>
+          <a:prstGeom prst="rect">
+            <a:avLst/>
+          </a:prstGeom>
+          <a:solidFill>
+            <a:srgbClr val="F6F8FC"/>
+          </a:solidFill>
+          <a:ln>
+            <a:solidFill>
+              <a:srgbClr val="D3DEEE"/>
+            </a:solidFill>
+          </a:ln>
+        </p:spPr>
+        <p:style>
+          <a:lnRef idx="2">
+            <a:schemeClr val="accent1">
+              <a:shade val="15000"/>
+            </a:schemeClr>
+          </a:lnRef>
+          <a:fillRef idx="1">
+            <a:schemeClr val="accent1"/>
+          </a:fillRef>
+          <a:effectRef idx="0">
+            <a:schemeClr val="accent1"/>
+          </a:effectRef>
+          <a:fontRef idx="minor">
+            <a:schemeClr val="lt1"/>
+          </a:fontRef>
+        </p:style>
+        <p:txBody>
+          <a:bodyPr rtlCol="0" anchor="ctr"/>
+          <a:lstStyle/>
+          <a:p>
+            <a:pPr algn="ctr"/>
+            <a:endParaRPr lang="en-US"/>
+          </a:p>
+        </p:txBody>
+      </p:sp>
+      <p:sp>
+        <p:nvSpPr>
+          <p:cNvPr id="30" name="Rectangle 29">
+            <a:extLst>
+              <a:ext uri="{FF2B5EF4-FFF2-40B4-BE49-F238E27FC236}">
+                <a16:creationId xmlns:a16="http://schemas.microsoft.com/office/drawing/2014/main" id="{784C38AF-D50D-3EDB-2A20-35E588144107}"/>
+              </a:ext>
+            </a:extLst>
+          </p:cNvPr>
+          <p:cNvSpPr/>
+          <p:nvPr/>
+        </p:nvSpPr>
+        <p:spPr>
+          <a:xfrm>
+            <a:off x="457200" y="5397500"/>
+            <a:ext cx="11252200" cy="787400"/>
+          </a:xfrm>
+          <a:prstGeom prst="rect">
+            <a:avLst/>
+          </a:prstGeom>
+          <a:solidFill>
+            <a:srgbClr val="002777"/>
+          </a:solidFill>
+          <a:ln w="12700" cap="flat" cmpd="sng" algn="ctr">
+            <a:noFill/>
+            <a:prstDash val="solid"/>
+            <a:miter lim="800000"/>
+          </a:ln>
+          <a:effectLst/>
+          <a:extLst>
+            <a:ext uri="{91240B29-F687-4F45-9708-019B960494DF}">
+              <a14:hiddenLine xmlns:a14="http://schemas.microsoft.com/office/drawing/2010/main" w="12700" cap="flat" cmpd="sng" algn="ctr">
+                <a:solidFill>
+                  <a:schemeClr val="accent1">
+                    <a:shade val="15000"/>
+                  </a:schemeClr>
+                </a:solidFill>
+                <a:prstDash val="solid"/>
+                <a:miter lim="800000"/>
+              </a14:hiddenLine>
+            </a:ext>
+          </a:extLst>
+        </p:spPr>
+        <p:style>
+          <a:lnRef idx="2">
+            <a:schemeClr val="accent1">
+              <a:shade val="15000"/>
+            </a:schemeClr>
+          </a:lnRef>
+          <a:fillRef idx="1">
+            <a:schemeClr val="accent1"/>
+          </a:fillRef>
+          <a:effectRef idx="0">
+            <a:schemeClr val="accent1"/>
+          </a:effectRef>
+          <a:fontRef idx="minor">
+            <a:schemeClr val="lt1"/>
+          </a:fontRef>
+        </p:style>
+        <p:txBody>
+          <a:bodyPr rtlCol="0" anchor="ctr"/>
+          <a:lstStyle/>
+          <a:p>
+            <a:pPr algn="ctr"/>
+            <a:endParaRPr lang="en-US"/>
+          </a:p>
+        </p:txBody>
+      </p:sp>
+      <p:sp>
+        <p:nvSpPr>
+          <p:cNvPr id="31" name="TextBox 30">
+            <a:extLst>
+              <a:ext uri="{FF2B5EF4-FFF2-40B4-BE49-F238E27FC236}">
+                <a16:creationId xmlns:a16="http://schemas.microsoft.com/office/drawing/2014/main" id="{78179848-0254-FC95-B234-981E0248F004}"/>
+              </a:ext>
+            </a:extLst>
+          </p:cNvPr>
+          <p:cNvSpPr txBox="1"/>
+          <p:nvPr/>
+        </p:nvSpPr>
+        <p:spPr>
+          <a:xfrm>
+            <a:off x="635000" y="5499100"/>
+            <a:ext cx="3429000" cy="276999"/>
+          </a:xfrm>
+          <a:prstGeom prst="rect">
+            <a:avLst/>
+          </a:prstGeom>
+          <a:noFill/>
+        </p:spPr>
+        <p:txBody>
+          <a:bodyPr vert="horz" wrap="square" lIns="0" tIns="0" rIns="0" bIns="0" rtlCol="0">
+            <a:noAutofit/>
+          </a:bodyPr>
+          <a:lstStyle/>
+          <a:p>
+            <a:r>
+              <a:rPr lang="en-US" sz="1050" b="1">
+                <a:solidFill>
+                  <a:srgbClr val="F37021"/>
+                </a:solidFill>
+                <a:latin typeface="Arial" panose="020B0604020202020204" pitchFamily="34" charset="0"/>
+              </a:rPr>
+              <a:t>FILE LOKAL</a:t>
+            </a:r>
+          </a:p>
+        </p:txBody>
+      </p:sp>
+      <p:sp>
+        <p:nvSpPr>
+          <p:cNvPr id="32" name="TextBox 31">
+            <a:extLst>
+              <a:ext uri="{FF2B5EF4-FFF2-40B4-BE49-F238E27FC236}">
+                <a16:creationId xmlns:a16="http://schemas.microsoft.com/office/drawing/2014/main" id="{9F041FD0-C768-9242-FF37-021E9D2B6BD9}"/>
+              </a:ext>
+            </a:extLst>
+          </p:cNvPr>
+          <p:cNvSpPr txBox="1"/>
+          <p:nvPr/>
+        </p:nvSpPr>
+        <p:spPr>
+          <a:xfrm>
+            <a:off x="635000" y="5727700"/>
+            <a:ext cx="3429000" cy="276999"/>
+          </a:xfrm>
+          <a:prstGeom prst="rect">
+            <a:avLst/>
+          </a:prstGeom>
+          <a:noFill/>
+        </p:spPr>
+        <p:txBody>
+          <a:bodyPr vert="horz" wrap="square" lIns="0" tIns="0" rIns="0" bIns="0" rtlCol="0">
+            <a:noAutofit/>
+          </a:bodyPr>
+          <a:lstStyle/>
+          <a:p>
+            <a:r>
+              <a:rPr lang="en-US" sz="1300">
+                <a:solidFill>
+                  <a:srgbClr val="FFFFFF"/>
+                </a:solidFill>
+                <a:latin typeface="Arial" panose="020B0604020202020204" pitchFamily="34" charset="0"/>
+              </a:rPr>
+              <a:t>.env dan password tersedia</a:t>
+            </a:r>
+          </a:p>
+        </p:txBody>
+      </p:sp>
+      <p:sp>
+        <p:nvSpPr>
+          <p:cNvPr id="33" name="TextBox 32">
+            <a:extLst>
+              <a:ext uri="{FF2B5EF4-FFF2-40B4-BE49-F238E27FC236}">
+                <a16:creationId xmlns:a16="http://schemas.microsoft.com/office/drawing/2014/main" id="{AF74B100-F150-BE1A-A13C-CBD2FCE7D19B}"/>
+              </a:ext>
+            </a:extLst>
+          </p:cNvPr>
+          <p:cNvSpPr txBox="1"/>
+          <p:nvPr/>
+        </p:nvSpPr>
+        <p:spPr>
+          <a:xfrm>
+            <a:off x="4318000" y="5499100"/>
+            <a:ext cx="3429000" cy="276999"/>
+          </a:xfrm>
+          <a:prstGeom prst="rect">
+            <a:avLst/>
+          </a:prstGeom>
+          <a:noFill/>
+        </p:spPr>
+        <p:txBody>
+          <a:bodyPr vert="horz" wrap="square" lIns="0" tIns="0" rIns="0" bIns="0" rtlCol="0">
+            <a:noAutofit/>
+          </a:bodyPr>
+          <a:lstStyle/>
+          <a:p>
+            <a:r>
+              <a:rPr lang="en-US" sz="1050" b="1">
+                <a:solidFill>
+                  <a:srgbClr val="F37021"/>
+                </a:solidFill>
+                <a:latin typeface="Arial" panose="020B0604020202020204" pitchFamily="34" charset="0"/>
+              </a:rPr>
+              <a:t>COMPOSE</a:t>
+            </a:r>
+          </a:p>
+        </p:txBody>
+      </p:sp>
+      <p:sp>
+        <p:nvSpPr>
+          <p:cNvPr id="34" name="TextBox 33">
+            <a:extLst>
+              <a:ext uri="{FF2B5EF4-FFF2-40B4-BE49-F238E27FC236}">
+                <a16:creationId xmlns:a16="http://schemas.microsoft.com/office/drawing/2014/main" id="{B864305D-94C1-CBA2-4912-2EC5B118054C}"/>
+              </a:ext>
+            </a:extLst>
+          </p:cNvPr>
+          <p:cNvSpPr txBox="1"/>
+          <p:nvPr/>
+        </p:nvSpPr>
+        <p:spPr>
+          <a:xfrm>
+            <a:off x="4318000" y="5727700"/>
+            <a:ext cx="3429000" cy="276999"/>
+          </a:xfrm>
+          <a:prstGeom prst="rect">
+            <a:avLst/>
+          </a:prstGeom>
+          <a:noFill/>
+        </p:spPr>
+        <p:txBody>
+          <a:bodyPr vert="horz" wrap="square" lIns="0" tIns="0" rIns="0" bIns="0" rtlCol="0">
+            <a:noAutofit/>
+          </a:bodyPr>
+          <a:lstStyle/>
+          <a:p>
+            <a:r>
+              <a:rPr lang="en-US" sz="1300">
+                <a:solidFill>
+                  <a:srgbClr val="FFFFFF"/>
+                </a:solidFill>
+                <a:latin typeface="Arial" panose="020B0604020202020204" pitchFamily="34" charset="0"/>
+              </a:rPr>
+              <a:t>config --quiet exit 0</a:t>
+            </a:r>
+          </a:p>
+        </p:txBody>
+      </p:sp>
+      <p:sp>
+        <p:nvSpPr>
+          <p:cNvPr id="35" name="TextBox 34">
+            <a:extLst>
+              <a:ext uri="{FF2B5EF4-FFF2-40B4-BE49-F238E27FC236}">
+                <a16:creationId xmlns:a16="http://schemas.microsoft.com/office/drawing/2014/main" id="{7FEE0EF9-5060-12FC-A5E6-E5367599FF83}"/>
+              </a:ext>
+            </a:extLst>
+          </p:cNvPr>
+          <p:cNvSpPr txBox="1"/>
+          <p:nvPr/>
+        </p:nvSpPr>
+        <p:spPr>
+          <a:xfrm>
+            <a:off x="8001000" y="5499100"/>
+            <a:ext cx="3429000" cy="276999"/>
+          </a:xfrm>
+          <a:prstGeom prst="rect">
+            <a:avLst/>
+          </a:prstGeom>
+          <a:noFill/>
+        </p:spPr>
+        <p:txBody>
+          <a:bodyPr vert="horz" wrap="square" lIns="0" tIns="0" rIns="0" bIns="0" rtlCol="0">
+            <a:noAutofit/>
+          </a:bodyPr>
+          <a:lstStyle/>
+          <a:p>
+            <a:r>
+              <a:rPr lang="en-US" sz="1050" b="1">
+                <a:solidFill>
+                  <a:srgbClr val="F37021"/>
+                </a:solidFill>
+                <a:latin typeface="Arial" panose="020B0604020202020204" pitchFamily="34" charset="0"/>
+              </a:rPr>
+              <a:t>GIT</a:t>
+            </a:r>
+          </a:p>
+        </p:txBody>
+      </p:sp>
+      <p:sp>
+        <p:nvSpPr>
+          <p:cNvPr id="36" name="TextBox 35">
+            <a:extLst>
+              <a:ext uri="{FF2B5EF4-FFF2-40B4-BE49-F238E27FC236}">
+                <a16:creationId xmlns:a16="http://schemas.microsoft.com/office/drawing/2014/main" id="{B7FAF8FA-E512-3BA5-B85A-15159888CAEB}"/>
+              </a:ext>
+            </a:extLst>
+          </p:cNvPr>
+          <p:cNvSpPr txBox="1"/>
+          <p:nvPr/>
+        </p:nvSpPr>
+        <p:spPr>
+          <a:xfrm>
+            <a:off x="8001000" y="5727700"/>
+            <a:ext cx="3429000" cy="276999"/>
+          </a:xfrm>
+          <a:prstGeom prst="rect">
+            <a:avLst/>
+          </a:prstGeom>
+          <a:noFill/>
+        </p:spPr>
+        <p:txBody>
+          <a:bodyPr vert="horz" wrap="square" lIns="0" tIns="0" rIns="0" bIns="0" rtlCol="0">
+            <a:noAutofit/>
+          </a:bodyPr>
+          <a:lstStyle/>
+          <a:p>
+            <a:r>
+              <a:rPr lang="en-US" sz="1300">
+                <a:solidFill>
+                  <a:srgbClr val="FFFFFF"/>
+                </a:solidFill>
+                <a:latin typeface="Arial" panose="020B0604020202020204" pitchFamily="34" charset="0"/>
+              </a:rPr>
+              <a:t>Kedua file diabaikan</a:t>
+            </a:r>
+          </a:p>
+        </p:txBody>
+      </p:sp>
+      <p:pic>
+        <p:nvPicPr>
+          <p:cNvPr id="37" name="Picture 36" descr="image.png"/>
+          <p:cNvPicPr>
+            <a:picLocks noChangeAspect="1"/>
+          </p:cNvPicPr>
+          <p:nvPr/>
+        </p:nvPicPr>
+        <p:blipFill>
+          <a:blip r:embed="rId4"/>
+          <a:stretch>
+            <a:fillRect/>
+          </a:stretch>
+        </p:blipFill>
+        <p:spPr>
+          <a:xfrm>
+            <a:off x="533400" y="1699723"/>
+            <a:ext cx="11099800" cy="3306154"/>
+          </a:xfrm>
+          <a:prstGeom prst="rect">
+            <a:avLst/>
+          </a:prstGeom>
+        </p:spPr>
+      </p:pic>
+    </p:spTree>
+  </p:cSld>
+  <p:clrMapOvr>
+    <a:masterClrMapping/>
+  </p:clrMapOvr>
+</p:sld>
+</file>
+
+<file path=ppt/slides/slide16.xml><?xml version="1.0" encoding="utf-8"?>
+<p:sld xmlns:a="http://schemas.openxmlformats.org/drawingml/2006/main" xmlns:p="http://schemas.openxmlformats.org/presentationml/2006/main" xmlns:r="http://schemas.openxmlformats.org/officeDocument/2006/relationships">
+  <p:cSld>
+    <p:spTree>
+      <p:nvGrpSpPr>
+        <p:cNvPr id="1" name=""/>
+        <p:cNvGrpSpPr/>
+        <p:nvPr/>
+      </p:nvGrpSpPr>
+      <p:grpSpPr/>
+      <p:sp>
+        <p:nvSpPr>
+          <p:cNvPr id="2" name="Text 0"/>
+          <p:cNvSpPr/>
+          <p:nvPr/>
+        </p:nvSpPr>
+        <p:spPr>
+          <a:xfrm>
+            <a:off x="457200" y="6492240"/>
+            <a:ext cx="7315200" cy="274320"/>
+          </a:xfrm>
+          <a:prstGeom prst="rect">
+            <a:avLst/>
+          </a:prstGeom>
+          <a:noFill/>
+          <a:ln/>
+        </p:spPr>
+        <p:txBody>
+          <a:bodyPr wrap="square" lIns="0" tIns="0" rIns="0" bIns="0" rtlCol="0" anchor="ctr"/>
+          <a:lstStyle/>
+          <a:p>
+            <a:pPr marL="0" indent="0" algn="l">
+              <a:buNone/>
+            </a:pPr>
+            <a:r>
+              <a:rPr lang="en-US" sz="900" dirty="0">
+                <a:solidFill>
+                  <a:srgbClr val="64748B"/>
+                </a:solidFill>
+                <a:latin typeface="Calibri" pitchFamily="34" charset="0"/>
+                <a:ea typeface="Calibri" pitchFamily="34" charset="-122"/>
+                <a:cs typeface="Calibri" pitchFamily="34" charset="-120"/>
+              </a:rPr>
+              <a:t>BINUS UNIVERSITY  |  Cloud Services  |  Praktikum 6</a:t>
+            </a:r>
+            <a:endParaRPr lang="en-US" sz="900" dirty="0"/>
+          </a:p>
+        </p:txBody>
+      </p:sp>
+      <p:sp>
+        <p:nvSpPr>
+          <p:cNvPr id="3" name="Text 1"/>
+          <p:cNvSpPr/>
+          <p:nvPr/>
+        </p:nvSpPr>
+        <p:spPr>
+          <a:xfrm>
+            <a:off x="11247120" y="6492240"/>
+            <a:ext cx="457200" cy="274320"/>
+          </a:xfrm>
+          <a:prstGeom prst="rect">
+            <a:avLst/>
+          </a:prstGeom>
+          <a:noFill/>
+          <a:ln/>
+        </p:spPr>
+        <p:txBody>
+          <a:bodyPr wrap="square" lIns="0" tIns="0" rIns="0" bIns="0" rtlCol="0" anchor="ctr"/>
+          <a:lstStyle/>
+          <a:p>
+            <a:pPr marL="0" indent="0" algn="r">
+              <a:buNone/>
+            </a:pPr>
+            <a:r>
+              <a:rPr lang="en-US" sz="900" b="1">
+                <a:solidFill>
+                  <a:srgbClr val="64748B"/>
+                </a:solidFill>
+                <a:latin typeface="Calibri" pitchFamily="34" charset="0"/>
+                <a:ea typeface="Calibri" pitchFamily="34" charset="-122"/>
+                <a:cs typeface="Calibri" pitchFamily="34" charset="-120"/>
+              </a:rPr>
+              <a:t>16</a:t>
+            </a:r>
+            <a:endParaRPr lang="en-US" sz="900" dirty="0"/>
+          </a:p>
+        </p:txBody>
+      </p:sp>
+      <p:sp>
+        <p:nvSpPr>
+          <p:cNvPr id="4" name="Shape 2"/>
+          <p:cNvSpPr/>
+          <p:nvPr/>
+        </p:nvSpPr>
+        <p:spPr>
+          <a:xfrm>
+            <a:off x="457200" y="6446520"/>
+            <a:ext cx="228600" cy="36576"/>
+          </a:xfrm>
+          <a:prstGeom prst="rect">
+            <a:avLst/>
+          </a:prstGeom>
+          <a:solidFill>
+            <a:srgbClr val="F37021"/>
+          </a:solidFill>
+          <a:ln w="12700">
+            <a:solidFill>
+              <a:srgbClr val="F37021"/>
+            </a:solidFill>
+            <a:prstDash val="solid"/>
+          </a:ln>
+        </p:spPr>
+      </p:sp>
+      <p:pic>
+        <p:nvPicPr>
+          <p:cNvPr id="5" name="Picture 4" descr="image.png"/>
+          <p:cNvPicPr>
+            <a:picLocks noChangeAspect="1"/>
+          </p:cNvPicPr>
+          <p:nvPr/>
+        </p:nvPicPr>
+        <p:blipFill>
+          <a:blip r:embed="rId2"/>
+          <a:stretch>
+            <a:fillRect/>
+          </a:stretch>
+        </p:blipFill>
+        <p:spPr>
+          <a:xfrm>
+            <a:off x="274320" y="164592"/>
+            <a:ext cx="914400" cy="603504"/>
+          </a:xfrm>
+          <a:prstGeom prst="rect">
+            <a:avLst/>
+          </a:prstGeom>
+        </p:spPr>
+      </p:pic>
+      <p:pic>
+        <p:nvPicPr>
+          <p:cNvPr id="6" name="Picture 5" descr="image.png"/>
+          <p:cNvPicPr>
+            <a:picLocks noChangeAspect="1"/>
+          </p:cNvPicPr>
+          <p:nvPr/>
+        </p:nvPicPr>
+        <p:blipFill>
+          <a:blip r:embed="rId3"/>
+          <a:stretch>
+            <a:fillRect/>
+          </a:stretch>
+        </p:blipFill>
+        <p:spPr>
+          <a:xfrm>
+            <a:off x="10881360" y="182880"/>
+            <a:ext cx="1005840" cy="512064"/>
+          </a:xfrm>
+          <a:prstGeom prst="rect">
+            <a:avLst/>
+          </a:prstGeom>
+        </p:spPr>
+      </p:pic>
+      <p:sp>
+        <p:nvSpPr>
+          <p:cNvPr id="7" name="Shape 3"/>
+          <p:cNvSpPr/>
+          <p:nvPr/>
+        </p:nvSpPr>
+        <p:spPr>
+          <a:xfrm>
+            <a:off x="457200" y="868680"/>
+            <a:ext cx="11247120" cy="0"/>
+          </a:xfrm>
+          <a:prstGeom prst="line">
+            <a:avLst/>
+          </a:prstGeom>
+          <a:noFill/>
+          <a:ln w="12700">
+            <a:solidFill>
+              <a:srgbClr val="E2E8F0"/>
+            </a:solidFill>
+            <a:prstDash val="solid"/>
+          </a:ln>
+        </p:spPr>
+      </p:sp>
+      <p:sp>
+        <p:nvSpPr>
+          <p:cNvPr id="8" name="Text 4"/>
+          <p:cNvSpPr/>
+          <p:nvPr/>
+        </p:nvSpPr>
+        <p:spPr>
+          <a:xfrm>
+            <a:off x="2011680" y="182880"/>
+            <a:ext cx="8138160" cy="502920"/>
+          </a:xfrm>
+          <a:prstGeom prst="rect">
+            <a:avLst/>
+          </a:prstGeom>
+          <a:noFill/>
+          <a:ln/>
+        </p:spPr>
+        <p:txBody>
+          <a:bodyPr wrap="square" lIns="0" tIns="0" rIns="0" bIns="0" rtlCol="0" anchor="ctr"/>
+          <a:lstStyle/>
+          <a:p>
+            <a:pPr marL="0" indent="0" algn="ctr">
+              <a:buNone/>
+            </a:pPr>
+            <a:r>
+              <a:rPr lang="nl-NL" sz="2200" b="1">
+                <a:solidFill>
+                  <a:srgbClr val="1976D2"/>
+                </a:solidFill>
+                <a:latin typeface="Calibri" pitchFamily="34" charset="0"/>
+                <a:ea typeface="Calibri" pitchFamily="34" charset="-122"/>
+                <a:cs typeface="Calibri" pitchFamily="34" charset="-120"/>
+              </a:rPr>
+              <a:t>Bukti DNS | service dan health</a:t>
+            </a:r>
+            <a:endParaRPr lang="en-US" sz="2200" dirty="0"/>
+          </a:p>
+        </p:txBody>
+      </p:sp>
+      <p:sp>
+        <p:nvSpPr>
+          <p:cNvPr id="9" name="Text 5"/>
+          <p:cNvSpPr/>
+          <p:nvPr/>
+        </p:nvSpPr>
+        <p:spPr>
+          <a:xfrm>
+            <a:off x="457200" y="960120"/>
+            <a:ext cx="11247120" cy="320040"/>
+          </a:xfrm>
+          <a:prstGeom prst="rect">
+            <a:avLst/>
+          </a:prstGeom>
+          <a:noFill/>
+          <a:ln/>
+        </p:spPr>
+        <p:txBody>
+          <a:bodyPr wrap="square" lIns="0" tIns="0" rIns="0" bIns="0" rtlCol="0" anchor="ctr"/>
+          <a:lstStyle/>
+          <a:p>
+            <a:pPr marL="0" indent="0" algn="ctr">
+              <a:buNone/>
+            </a:pPr>
+            <a:r>
+              <a:rPr lang="en-US" sz="1200" i="1">
+                <a:solidFill>
+                  <a:srgbClr val="64748B"/>
+                </a:solidFill>
+                <a:latin typeface="Calibri" pitchFamily="34" charset="0"/>
+                <a:ea typeface="Calibri" pitchFamily="34" charset="-122"/>
+                <a:cs typeface="Calibri" pitchFamily="34" charset="-120"/>
+              </a:rPr>
+              <a:t>getent hosts; GET /health  |  output aktual</a:t>
+            </a:r>
+            <a:endParaRPr lang="en-US" sz="1200" dirty="0"/>
+          </a:p>
+        </p:txBody>
+      </p:sp>
+      <p:sp>
+        <p:nvSpPr>
+          <p:cNvPr id="27" name="Rectangle 26">
+            <a:extLst>
+              <a:ext uri="{FF2B5EF4-FFF2-40B4-BE49-F238E27FC236}">
+                <a16:creationId xmlns:a16="http://schemas.microsoft.com/office/drawing/2014/main" id="{CA2C3FC3-2268-3632-60A5-8F36FCCD90BB}"/>
+              </a:ext>
+            </a:extLst>
+          </p:cNvPr>
+          <p:cNvSpPr/>
+          <p:nvPr/>
+        </p:nvSpPr>
+        <p:spPr>
+          <a:xfrm>
+            <a:off x="457200" y="1409700"/>
+            <a:ext cx="11252200" cy="3886200"/>
+          </a:xfrm>
+          <a:prstGeom prst="rect">
+            <a:avLst/>
+          </a:prstGeom>
+          <a:solidFill>
+            <a:srgbClr val="F6F8FC"/>
+          </a:solidFill>
+          <a:ln>
+            <a:solidFill>
+              <a:srgbClr val="D3DEEE"/>
+            </a:solidFill>
+          </a:ln>
+        </p:spPr>
+        <p:style>
+          <a:lnRef idx="2">
+            <a:schemeClr val="accent1">
+              <a:shade val="15000"/>
+            </a:schemeClr>
+          </a:lnRef>
+          <a:fillRef idx="1">
+            <a:schemeClr val="accent1"/>
+          </a:fillRef>
+          <a:effectRef idx="0">
+            <a:schemeClr val="accent1"/>
+          </a:effectRef>
+          <a:fontRef idx="minor">
+            <a:schemeClr val="lt1"/>
+          </a:fontRef>
+        </p:style>
+        <p:txBody>
+          <a:bodyPr rtlCol="0" anchor="ctr"/>
+          <a:lstStyle/>
+          <a:p>
+            <a:pPr algn="ctr"/>
+            <a:endParaRPr lang="en-US"/>
+          </a:p>
+        </p:txBody>
+      </p:sp>
+      <p:sp>
+        <p:nvSpPr>
+          <p:cNvPr id="30" name="Rectangle 29">
+            <a:extLst>
+              <a:ext uri="{FF2B5EF4-FFF2-40B4-BE49-F238E27FC236}">
+                <a16:creationId xmlns:a16="http://schemas.microsoft.com/office/drawing/2014/main" id="{784C38AF-D50D-3EDB-2A20-35E588144107}"/>
+              </a:ext>
+            </a:extLst>
+          </p:cNvPr>
+          <p:cNvSpPr/>
+          <p:nvPr/>
+        </p:nvSpPr>
+        <p:spPr>
+          <a:xfrm>
+            <a:off x="457200" y="5397500"/>
+            <a:ext cx="11252200" cy="787400"/>
+          </a:xfrm>
+          <a:prstGeom prst="rect">
+            <a:avLst/>
+          </a:prstGeom>
+          <a:solidFill>
+            <a:srgbClr val="002777"/>
+          </a:solidFill>
+          <a:ln w="12700" cap="flat" cmpd="sng" algn="ctr">
+            <a:noFill/>
+            <a:prstDash val="solid"/>
+            <a:miter lim="800000"/>
+          </a:ln>
+          <a:effectLst/>
+          <a:extLst>
+            <a:ext uri="{91240B29-F687-4F45-9708-019B960494DF}">
+              <a14:hiddenLine xmlns:a14="http://schemas.microsoft.com/office/drawing/2010/main" w="12700" cap="flat" cmpd="sng" algn="ctr">
+                <a:solidFill>
+                  <a:schemeClr val="accent1">
+                    <a:shade val="15000"/>
+                  </a:schemeClr>
+                </a:solidFill>
+                <a:prstDash val="solid"/>
+                <a:miter lim="800000"/>
+              </a14:hiddenLine>
+            </a:ext>
+          </a:extLst>
+        </p:spPr>
+        <p:style>
+          <a:lnRef idx="2">
+            <a:schemeClr val="accent1">
+              <a:shade val="15000"/>
+            </a:schemeClr>
+          </a:lnRef>
+          <a:fillRef idx="1">
+            <a:schemeClr val="accent1"/>
+          </a:fillRef>
+          <a:effectRef idx="0">
+            <a:schemeClr val="accent1"/>
+          </a:effectRef>
+          <a:fontRef idx="minor">
+            <a:schemeClr val="lt1"/>
+          </a:fontRef>
+        </p:style>
+        <p:txBody>
+          <a:bodyPr rtlCol="0" anchor="ctr"/>
+          <a:lstStyle/>
+          <a:p>
+            <a:pPr algn="ctr"/>
+            <a:endParaRPr lang="en-US"/>
+          </a:p>
+        </p:txBody>
+      </p:sp>
+      <p:sp>
+        <p:nvSpPr>
+          <p:cNvPr id="31" name="TextBox 30">
+            <a:extLst>
+              <a:ext uri="{FF2B5EF4-FFF2-40B4-BE49-F238E27FC236}">
+                <a16:creationId xmlns:a16="http://schemas.microsoft.com/office/drawing/2014/main" id="{78179848-0254-FC95-B234-981E0248F004}"/>
+              </a:ext>
+            </a:extLst>
+          </p:cNvPr>
+          <p:cNvSpPr txBox="1"/>
+          <p:nvPr/>
+        </p:nvSpPr>
+        <p:spPr>
+          <a:xfrm>
+            <a:off x="635000" y="5499100"/>
+            <a:ext cx="3429000" cy="276999"/>
+          </a:xfrm>
+          <a:prstGeom prst="rect">
+            <a:avLst/>
+          </a:prstGeom>
+          <a:noFill/>
+        </p:spPr>
+        <p:txBody>
+          <a:bodyPr vert="horz" wrap="square" lIns="0" tIns="0" rIns="0" bIns="0" rtlCol="0">
+            <a:noAutofit/>
+          </a:bodyPr>
+          <a:lstStyle/>
+          <a:p>
+            <a:r>
+              <a:rPr lang="en-US" sz="1050" b="1">
+                <a:solidFill>
+                  <a:srgbClr val="F37021"/>
+                </a:solidFill>
+                <a:latin typeface="Arial" panose="020B0604020202020204" pitchFamily="34" charset="0"/>
+              </a:rPr>
+              <a:t>DNS</a:t>
+            </a:r>
+          </a:p>
+        </p:txBody>
+      </p:sp>
+      <p:sp>
+        <p:nvSpPr>
+          <p:cNvPr id="32" name="TextBox 31">
+            <a:extLst>
+              <a:ext uri="{FF2B5EF4-FFF2-40B4-BE49-F238E27FC236}">
+                <a16:creationId xmlns:a16="http://schemas.microsoft.com/office/drawing/2014/main" id="{9F041FD0-C768-9242-FF37-021E9D2B6BD9}"/>
+              </a:ext>
+            </a:extLst>
+          </p:cNvPr>
+          <p:cNvSpPr txBox="1"/>
+          <p:nvPr/>
+        </p:nvSpPr>
+        <p:spPr>
+          <a:xfrm>
+            <a:off x="635000" y="5727700"/>
+            <a:ext cx="3429000" cy="276999"/>
+          </a:xfrm>
+          <a:prstGeom prst="rect">
+            <a:avLst/>
+          </a:prstGeom>
+          <a:noFill/>
+        </p:spPr>
+        <p:txBody>
+          <a:bodyPr vert="horz" wrap="square" lIns="0" tIns="0" rIns="0" bIns="0" rtlCol="0">
+            <a:noAutofit/>
+          </a:bodyPr>
+          <a:lstStyle/>
+          <a:p>
+            <a:r>
+              <a:rPr lang="en-US" sz="1300">
+                <a:solidFill>
+                  <a:srgbClr val="FFFFFF"/>
+                </a:solidFill>
+                <a:latin typeface="Arial" panose="020B0604020202020204" pitchFamily="34" charset="0"/>
+              </a:rPr>
+              <a:t>db dan cache punya alamat</a:t>
+            </a:r>
+          </a:p>
+        </p:txBody>
+      </p:sp>
+      <p:sp>
+        <p:nvSpPr>
+          <p:cNvPr id="33" name="TextBox 32">
+            <a:extLst>
+              <a:ext uri="{FF2B5EF4-FFF2-40B4-BE49-F238E27FC236}">
+                <a16:creationId xmlns:a16="http://schemas.microsoft.com/office/drawing/2014/main" id="{AF74B100-F150-BE1A-A13C-CBD2FCE7D19B}"/>
+              </a:ext>
+            </a:extLst>
+          </p:cNvPr>
+          <p:cNvSpPr txBox="1"/>
+          <p:nvPr/>
+        </p:nvSpPr>
+        <p:spPr>
+          <a:xfrm>
+            <a:off x="4318000" y="5499100"/>
+            <a:ext cx="3429000" cy="276999"/>
+          </a:xfrm>
+          <a:prstGeom prst="rect">
+            <a:avLst/>
+          </a:prstGeom>
+          <a:noFill/>
+        </p:spPr>
+        <p:txBody>
+          <a:bodyPr vert="horz" wrap="square" lIns="0" tIns="0" rIns="0" bIns="0" rtlCol="0">
+            <a:noAutofit/>
+          </a:bodyPr>
+          <a:lstStyle/>
+          <a:p>
+            <a:r>
+              <a:rPr lang="en-US" sz="1050" b="1">
+                <a:solidFill>
+                  <a:srgbClr val="F37021"/>
+                </a:solidFill>
+                <a:latin typeface="Arial" panose="020B0604020202020204" pitchFamily="34" charset="0"/>
+              </a:rPr>
+              <a:t>NETWORK</a:t>
+            </a:r>
+          </a:p>
+        </p:txBody>
+      </p:sp>
+      <p:sp>
+        <p:nvSpPr>
+          <p:cNvPr id="34" name="TextBox 33">
+            <a:extLst>
+              <a:ext uri="{FF2B5EF4-FFF2-40B4-BE49-F238E27FC236}">
+                <a16:creationId xmlns:a16="http://schemas.microsoft.com/office/drawing/2014/main" id="{B864305D-94C1-CBA2-4912-2EC5B118054C}"/>
+              </a:ext>
+            </a:extLst>
+          </p:cNvPr>
+          <p:cNvSpPr txBox="1"/>
+          <p:nvPr/>
+        </p:nvSpPr>
+        <p:spPr>
+          <a:xfrm>
+            <a:off x="4318000" y="5727700"/>
+            <a:ext cx="3429000" cy="276999"/>
+          </a:xfrm>
+          <a:prstGeom prst="rect">
+            <a:avLst/>
+          </a:prstGeom>
+          <a:noFill/>
+        </p:spPr>
+        <p:txBody>
+          <a:bodyPr vert="horz" wrap="square" lIns="0" tIns="0" rIns="0" bIns="0" rtlCol="0">
+            <a:noAutofit/>
+          </a:bodyPr>
+          <a:lstStyle/>
+          <a:p>
+            <a:r>
+              <a:rPr lang="en-US" sz="1300">
+                <a:solidFill>
+                  <a:srgbClr val="FFFFFF"/>
+                </a:solidFill>
+                <a:latin typeface="Arial" panose="020B0604020202020204" pitchFamily="34" charset="0"/>
+              </a:rPr>
+              <a:t>IP internal dapat berubah</a:t>
+            </a:r>
+          </a:p>
+        </p:txBody>
+      </p:sp>
+      <p:sp>
+        <p:nvSpPr>
+          <p:cNvPr id="35" name="TextBox 34">
+            <a:extLst>
+              <a:ext uri="{FF2B5EF4-FFF2-40B4-BE49-F238E27FC236}">
+                <a16:creationId xmlns:a16="http://schemas.microsoft.com/office/drawing/2014/main" id="{7FEE0EF9-5060-12FC-A5E6-E5367599FF83}"/>
+              </a:ext>
+            </a:extLst>
+          </p:cNvPr>
+          <p:cNvSpPr txBox="1"/>
+          <p:nvPr/>
+        </p:nvSpPr>
+        <p:spPr>
+          <a:xfrm>
+            <a:off x="8001000" y="5499100"/>
+            <a:ext cx="3429000" cy="276999"/>
+          </a:xfrm>
+          <a:prstGeom prst="rect">
+            <a:avLst/>
+          </a:prstGeom>
+          <a:noFill/>
+        </p:spPr>
+        <p:txBody>
+          <a:bodyPr vert="horz" wrap="square" lIns="0" tIns="0" rIns="0" bIns="0" rtlCol="0">
+            <a:noAutofit/>
+          </a:bodyPr>
+          <a:lstStyle/>
+          <a:p>
+            <a:r>
+              <a:rPr lang="en-US" sz="1050" b="1">
+                <a:solidFill>
+                  <a:srgbClr val="F37021"/>
+                </a:solidFill>
+                <a:latin typeface="Arial" panose="020B0604020202020204" pitchFamily="34" charset="0"/>
+              </a:rPr>
+              <a:t>HTTP</a:t>
+            </a:r>
+          </a:p>
+        </p:txBody>
+      </p:sp>
+      <p:sp>
+        <p:nvSpPr>
+          <p:cNvPr id="36" name="TextBox 35">
+            <a:extLst>
+              <a:ext uri="{FF2B5EF4-FFF2-40B4-BE49-F238E27FC236}">
+                <a16:creationId xmlns:a16="http://schemas.microsoft.com/office/drawing/2014/main" id="{B7FAF8FA-E512-3BA5-B85A-15159888CAEB}"/>
+              </a:ext>
+            </a:extLst>
+          </p:cNvPr>
+          <p:cNvSpPr txBox="1"/>
+          <p:nvPr/>
+        </p:nvSpPr>
+        <p:spPr>
+          <a:xfrm>
+            <a:off x="8001000" y="5727700"/>
+            <a:ext cx="3429000" cy="276999"/>
+          </a:xfrm>
+          <a:prstGeom prst="rect">
+            <a:avLst/>
+          </a:prstGeom>
+          <a:noFill/>
+        </p:spPr>
+        <p:txBody>
+          <a:bodyPr vert="horz" wrap="square" lIns="0" tIns="0" rIns="0" bIns="0" rtlCol="0">
+            <a:noAutofit/>
+          </a:bodyPr>
+          <a:lstStyle/>
+          <a:p>
+            <a:r>
+              <a:rPr lang="en-US" sz="1300">
+                <a:solidFill>
+                  <a:srgbClr val="FFFFFF"/>
+                </a:solidFill>
+                <a:latin typeface="Arial" panose="020B0604020202020204" pitchFamily="34" charset="0"/>
+              </a:rPr>
+              <a:t>Health 200 dan JSON ok</a:t>
+            </a:r>
+          </a:p>
+        </p:txBody>
+      </p:sp>
+      <p:pic>
+        <p:nvPicPr>
+          <p:cNvPr id="37" name="Picture 36" descr="image.png"/>
+          <p:cNvPicPr>
+            <a:picLocks noChangeAspect="1"/>
+          </p:cNvPicPr>
+          <p:nvPr/>
+        </p:nvPicPr>
+        <p:blipFill>
+          <a:blip r:embed="rId4"/>
+          <a:stretch>
+            <a:fillRect/>
+          </a:stretch>
+        </p:blipFill>
+        <p:spPr>
+          <a:xfrm>
+            <a:off x="1118228" y="1490898"/>
+            <a:ext cx="9930144" cy="3723804"/>
+          </a:xfrm>
+          <a:prstGeom prst="rect">
+            <a:avLst/>
+          </a:prstGeom>
+        </p:spPr>
+      </p:pic>
+    </p:spTree>
+  </p:cSld>
+  <p:clrMapOvr>
+    <a:masterClrMapping/>
+  </p:clrMapOvr>
+</p:sld>
+</file>
+
+<file path=ppt/slides/slide17.xml><?xml version="1.0" encoding="utf-8"?>
+<p:sld xmlns:a="http://schemas.openxmlformats.org/drawingml/2006/main" xmlns:p="http://schemas.openxmlformats.org/presentationml/2006/main" xmlns:r="http://schemas.openxmlformats.org/officeDocument/2006/relationships">
+  <p:cSld>
+    <p:spTree>
+      <p:nvGrpSpPr>
+        <p:cNvPr id="1" name=""/>
+        <p:cNvGrpSpPr/>
+        <p:nvPr/>
+      </p:nvGrpSpPr>
+      <p:grpSpPr/>
+      <p:sp>
+        <p:nvSpPr>
+          <p:cNvPr id="2" name="Text 0"/>
+          <p:cNvSpPr/>
+          <p:nvPr/>
+        </p:nvSpPr>
+        <p:spPr>
+          <a:xfrm>
+            <a:off x="457200" y="6492240"/>
+            <a:ext cx="7315200" cy="274320"/>
+          </a:xfrm>
+          <a:prstGeom prst="rect">
+            <a:avLst/>
+          </a:prstGeom>
+          <a:noFill/>
+          <a:ln/>
+        </p:spPr>
+        <p:txBody>
+          <a:bodyPr wrap="square" lIns="0" tIns="0" rIns="0" bIns="0" rtlCol="0" anchor="ctr"/>
+          <a:lstStyle/>
+          <a:p>
+            <a:pPr marL="0" indent="0" algn="l">
+              <a:buNone/>
+            </a:pPr>
+            <a:r>
+              <a:rPr lang="en-US" sz="900" dirty="0">
+                <a:solidFill>
+                  <a:srgbClr val="64748B"/>
+                </a:solidFill>
+                <a:latin typeface="Calibri" pitchFamily="34" charset="0"/>
+                <a:ea typeface="Calibri" pitchFamily="34" charset="-122"/>
+                <a:cs typeface="Calibri" pitchFamily="34" charset="-120"/>
+              </a:rPr>
+              <a:t>BINUS UNIVERSITY  |  Cloud Services  |  Praktikum 6</a:t>
+            </a:r>
+            <a:endParaRPr lang="en-US" sz="900" dirty="0"/>
+          </a:p>
+        </p:txBody>
+      </p:sp>
+      <p:sp>
+        <p:nvSpPr>
+          <p:cNvPr id="3" name="Text 1"/>
+          <p:cNvSpPr/>
+          <p:nvPr/>
+        </p:nvSpPr>
+        <p:spPr>
+          <a:xfrm>
+            <a:off x="11247120" y="6492240"/>
+            <a:ext cx="457200" cy="274320"/>
+          </a:xfrm>
+          <a:prstGeom prst="rect">
+            <a:avLst/>
+          </a:prstGeom>
+          <a:noFill/>
+          <a:ln/>
+        </p:spPr>
+        <p:txBody>
+          <a:bodyPr wrap="square" lIns="0" tIns="0" rIns="0" bIns="0" rtlCol="0" anchor="ctr"/>
+          <a:lstStyle/>
+          <a:p>
+            <a:pPr marL="0" indent="0" algn="r">
+              <a:buNone/>
+            </a:pPr>
+            <a:r>
+              <a:rPr lang="en-US" sz="900" b="1">
+                <a:solidFill>
+                  <a:srgbClr val="64748B"/>
+                </a:solidFill>
+                <a:latin typeface="Calibri" pitchFamily="34" charset="0"/>
+                <a:ea typeface="Calibri" pitchFamily="34" charset="-122"/>
+                <a:cs typeface="Calibri" pitchFamily="34" charset="-120"/>
+              </a:rPr>
+              <a:t>17</a:t>
+            </a:r>
+            <a:endParaRPr lang="en-US" sz="900" dirty="0"/>
+          </a:p>
+        </p:txBody>
+      </p:sp>
+      <p:sp>
+        <p:nvSpPr>
+          <p:cNvPr id="4" name="Shape 2"/>
+          <p:cNvSpPr/>
+          <p:nvPr/>
+        </p:nvSpPr>
+        <p:spPr>
+          <a:xfrm>
+            <a:off x="457200" y="6446520"/>
+            <a:ext cx="228600" cy="36576"/>
+          </a:xfrm>
+          <a:prstGeom prst="rect">
+            <a:avLst/>
+          </a:prstGeom>
+          <a:solidFill>
+            <a:srgbClr val="F37021"/>
+          </a:solidFill>
+          <a:ln w="12700">
+            <a:solidFill>
+              <a:srgbClr val="F37021"/>
+            </a:solidFill>
+            <a:prstDash val="solid"/>
+          </a:ln>
+        </p:spPr>
+      </p:sp>
+      <p:pic>
+        <p:nvPicPr>
+          <p:cNvPr id="5" name="Picture 4" descr="image.png"/>
+          <p:cNvPicPr>
+            <a:picLocks noChangeAspect="1"/>
+          </p:cNvPicPr>
+          <p:nvPr/>
+        </p:nvPicPr>
+        <p:blipFill>
+          <a:blip r:embed="rId2"/>
+          <a:stretch>
+            <a:fillRect/>
+          </a:stretch>
+        </p:blipFill>
+        <p:spPr>
+          <a:xfrm>
+            <a:off x="274320" y="164592"/>
+            <a:ext cx="914400" cy="603504"/>
+          </a:xfrm>
+          <a:prstGeom prst="rect">
+            <a:avLst/>
+          </a:prstGeom>
+        </p:spPr>
+      </p:pic>
+      <p:pic>
+        <p:nvPicPr>
+          <p:cNvPr id="6" name="Picture 5" descr="image.png"/>
+          <p:cNvPicPr>
+            <a:picLocks noChangeAspect="1"/>
+          </p:cNvPicPr>
+          <p:nvPr/>
+        </p:nvPicPr>
+        <p:blipFill>
+          <a:blip r:embed="rId3"/>
+          <a:stretch>
+            <a:fillRect/>
+          </a:stretch>
+        </p:blipFill>
+        <p:spPr>
+          <a:xfrm>
+            <a:off x="10881360" y="182880"/>
+            <a:ext cx="1005840" cy="512064"/>
+          </a:xfrm>
+          <a:prstGeom prst="rect">
+            <a:avLst/>
+          </a:prstGeom>
+        </p:spPr>
+      </p:pic>
+      <p:sp>
+        <p:nvSpPr>
+          <p:cNvPr id="7" name="Shape 3"/>
+          <p:cNvSpPr/>
+          <p:nvPr/>
+        </p:nvSpPr>
+        <p:spPr>
+          <a:xfrm>
+            <a:off x="457200" y="868680"/>
+            <a:ext cx="11247120" cy="0"/>
+          </a:xfrm>
+          <a:prstGeom prst="line">
+            <a:avLst/>
+          </a:prstGeom>
+          <a:noFill/>
+          <a:ln w="12700">
+            <a:solidFill>
+              <a:srgbClr val="E2E8F0"/>
+            </a:solidFill>
+            <a:prstDash val="solid"/>
+          </a:ln>
+        </p:spPr>
+      </p:sp>
+      <p:sp>
+        <p:nvSpPr>
+          <p:cNvPr id="8" name="Text 4"/>
+          <p:cNvSpPr/>
+          <p:nvPr/>
+        </p:nvSpPr>
+        <p:spPr>
+          <a:xfrm>
+            <a:off x="2011680" y="182880"/>
+            <a:ext cx="8138160" cy="502920"/>
+          </a:xfrm>
+          <a:prstGeom prst="rect">
+            <a:avLst/>
+          </a:prstGeom>
+          <a:noFill/>
+          <a:ln/>
+        </p:spPr>
+        <p:txBody>
+          <a:bodyPr wrap="square" lIns="0" tIns="0" rIns="0" bIns="0" rtlCol="0" anchor="ctr"/>
+          <a:lstStyle/>
+          <a:p>
+            <a:pPr marL="0" indent="0" algn="ctr">
+              <a:buNone/>
+            </a:pPr>
+            <a:r>
+              <a:rPr lang="nl-NL" sz="2200" b="1">
+                <a:solidFill>
+                  <a:srgbClr val="1976D2"/>
+                </a:solidFill>
+                <a:latin typeface="Calibri" pitchFamily="34" charset="0"/>
+                <a:ea typeface="Calibri" pitchFamily="34" charset="-122"/>
+                <a:cs typeface="Calibri" pitchFamily="34" charset="-120"/>
+              </a:rPr>
+              <a:t>Bukti Git | repo Lab 06 terbit</a:t>
+            </a:r>
+            <a:endParaRPr lang="en-US" sz="2200" dirty="0"/>
+          </a:p>
+        </p:txBody>
+      </p:sp>
+      <p:sp>
+        <p:nvSpPr>
+          <p:cNvPr id="9" name="Text 5"/>
+          <p:cNvSpPr/>
+          <p:nvPr/>
+        </p:nvSpPr>
+        <p:spPr>
+          <a:xfrm>
+            <a:off x="457200" y="960120"/>
+            <a:ext cx="11247120" cy="320040"/>
+          </a:xfrm>
+          <a:prstGeom prst="rect">
+            <a:avLst/>
+          </a:prstGeom>
+          <a:noFill/>
+          <a:ln/>
+        </p:spPr>
+        <p:txBody>
+          <a:bodyPr wrap="square" lIns="0" tIns="0" rIns="0" bIns="0" rtlCol="0" anchor="ctr"/>
+          <a:lstStyle/>
+          <a:p>
+            <a:pPr marL="0" indent="0" algn="ctr">
+              <a:buNone/>
+            </a:pPr>
+            <a:r>
+              <a:rPr lang="en-US" sz="1200" i="1">
+                <a:solidFill>
+                  <a:srgbClr val="64748B"/>
+                </a:solidFill>
+                <a:latin typeface="Calibri" pitchFamily="34" charset="0"/>
+                <a:ea typeface="Calibri" pitchFamily="34" charset="-122"/>
+                <a:cs typeface="Calibri" pitchFamily="34" charset="-120"/>
+              </a:rPr>
+              <a:t>remote, status, log, SHA main  |  contoh checkpoint pengajar</a:t>
+            </a:r>
+            <a:endParaRPr lang="en-US" sz="1200" dirty="0"/>
+          </a:p>
+        </p:txBody>
+      </p:sp>
+      <p:sp>
+        <p:nvSpPr>
+          <p:cNvPr id="27" name="Rectangle 26">
+            <a:extLst>
+              <a:ext uri="{FF2B5EF4-FFF2-40B4-BE49-F238E27FC236}">
+                <a16:creationId xmlns:a16="http://schemas.microsoft.com/office/drawing/2014/main" id="{CA2C3FC3-2268-3632-60A5-8F36FCCD90BB}"/>
+              </a:ext>
+            </a:extLst>
+          </p:cNvPr>
+          <p:cNvSpPr/>
+          <p:nvPr/>
+        </p:nvSpPr>
+        <p:spPr>
+          <a:xfrm>
+            <a:off x="457200" y="1409700"/>
+            <a:ext cx="11252200" cy="3886200"/>
+          </a:xfrm>
+          <a:prstGeom prst="rect">
+            <a:avLst/>
+          </a:prstGeom>
+          <a:solidFill>
+            <a:srgbClr val="F6F8FC"/>
+          </a:solidFill>
+          <a:ln>
+            <a:solidFill>
+              <a:srgbClr val="D3DEEE"/>
+            </a:solidFill>
+          </a:ln>
+        </p:spPr>
+        <p:style>
+          <a:lnRef idx="2">
+            <a:schemeClr val="accent1">
+              <a:shade val="15000"/>
+            </a:schemeClr>
+          </a:lnRef>
+          <a:fillRef idx="1">
+            <a:schemeClr val="accent1"/>
+          </a:fillRef>
+          <a:effectRef idx="0">
+            <a:schemeClr val="accent1"/>
+          </a:effectRef>
+          <a:fontRef idx="minor">
+            <a:schemeClr val="lt1"/>
+          </a:fontRef>
+        </p:style>
+        <p:txBody>
+          <a:bodyPr rtlCol="0" anchor="ctr"/>
+          <a:lstStyle/>
+          <a:p>
+            <a:pPr algn="ctr"/>
+            <a:endParaRPr lang="en-US"/>
+          </a:p>
+        </p:txBody>
+      </p:sp>
+      <p:sp>
+        <p:nvSpPr>
+          <p:cNvPr id="30" name="Rectangle 29">
+            <a:extLst>
+              <a:ext uri="{FF2B5EF4-FFF2-40B4-BE49-F238E27FC236}">
+                <a16:creationId xmlns:a16="http://schemas.microsoft.com/office/drawing/2014/main" id="{784C38AF-D50D-3EDB-2A20-35E588144107}"/>
+              </a:ext>
+            </a:extLst>
+          </p:cNvPr>
+          <p:cNvSpPr/>
+          <p:nvPr/>
+        </p:nvSpPr>
+        <p:spPr>
+          <a:xfrm>
+            <a:off x="457200" y="5397500"/>
+            <a:ext cx="11252200" cy="787400"/>
+          </a:xfrm>
+          <a:prstGeom prst="rect">
+            <a:avLst/>
+          </a:prstGeom>
+          <a:solidFill>
+            <a:srgbClr val="002777"/>
+          </a:solidFill>
+          <a:ln w="12700" cap="flat" cmpd="sng" algn="ctr">
+            <a:noFill/>
+            <a:prstDash val="solid"/>
+            <a:miter lim="800000"/>
+          </a:ln>
+          <a:effectLst/>
+          <a:extLst>
+            <a:ext uri="{91240B29-F687-4F45-9708-019B960494DF}">
+              <a14:hiddenLine xmlns:a14="http://schemas.microsoft.com/office/drawing/2010/main" w="12700" cap="flat" cmpd="sng" algn="ctr">
+                <a:solidFill>
+                  <a:schemeClr val="accent1">
+                    <a:shade val="15000"/>
+                  </a:schemeClr>
+                </a:solidFill>
+                <a:prstDash val="solid"/>
+                <a:miter lim="800000"/>
+              </a14:hiddenLine>
+            </a:ext>
+          </a:extLst>
+        </p:spPr>
+        <p:style>
+          <a:lnRef idx="2">
+            <a:schemeClr val="accent1">
+              <a:shade val="15000"/>
+            </a:schemeClr>
+          </a:lnRef>
+          <a:fillRef idx="1">
+            <a:schemeClr val="accent1"/>
+          </a:fillRef>
+          <a:effectRef idx="0">
+            <a:schemeClr val="accent1"/>
+          </a:effectRef>
+          <a:fontRef idx="minor">
+            <a:schemeClr val="lt1"/>
+          </a:fontRef>
+        </p:style>
+        <p:txBody>
+          <a:bodyPr rtlCol="0" anchor="ctr"/>
+          <a:lstStyle/>
+          <a:p>
+            <a:pPr algn="ctr"/>
+            <a:endParaRPr lang="en-US"/>
+          </a:p>
+        </p:txBody>
+      </p:sp>
+      <p:sp>
+        <p:nvSpPr>
+          <p:cNvPr id="31" name="TextBox 30">
+            <a:extLst>
+              <a:ext uri="{FF2B5EF4-FFF2-40B4-BE49-F238E27FC236}">
+                <a16:creationId xmlns:a16="http://schemas.microsoft.com/office/drawing/2014/main" id="{78179848-0254-FC95-B234-981E0248F004}"/>
+              </a:ext>
+            </a:extLst>
+          </p:cNvPr>
+          <p:cNvSpPr txBox="1"/>
+          <p:nvPr/>
+        </p:nvSpPr>
+        <p:spPr>
+          <a:xfrm>
+            <a:off x="635000" y="5499100"/>
+            <a:ext cx="3429000" cy="276999"/>
+          </a:xfrm>
+          <a:prstGeom prst="rect">
+            <a:avLst/>
+          </a:prstGeom>
+          <a:noFill/>
+        </p:spPr>
+        <p:txBody>
+          <a:bodyPr vert="horz" wrap="square" lIns="0" tIns="0" rIns="0" bIns="0" rtlCol="0">
+            <a:noAutofit/>
+          </a:bodyPr>
+          <a:lstStyle/>
+          <a:p>
+            <a:r>
+              <a:rPr lang="en-US" sz="1050" b="1">
+                <a:solidFill>
+                  <a:srgbClr val="F37021"/>
+                </a:solidFill>
+                <a:latin typeface="Arial" panose="020B0604020202020204" pitchFamily="34" charset="0"/>
+              </a:rPr>
+              <a:t>TUJUAN</a:t>
+            </a:r>
+          </a:p>
+        </p:txBody>
+      </p:sp>
+      <p:sp>
+        <p:nvSpPr>
+          <p:cNvPr id="32" name="TextBox 31">
+            <a:extLst>
+              <a:ext uri="{FF2B5EF4-FFF2-40B4-BE49-F238E27FC236}">
+                <a16:creationId xmlns:a16="http://schemas.microsoft.com/office/drawing/2014/main" id="{9F041FD0-C768-9242-FF37-021E9D2B6BD9}"/>
+              </a:ext>
+            </a:extLst>
+          </p:cNvPr>
+          <p:cNvSpPr txBox="1"/>
+          <p:nvPr/>
+        </p:nvSpPr>
+        <p:spPr>
+          <a:xfrm>
+            <a:off x="635000" y="5727700"/>
+            <a:ext cx="3429000" cy="276999"/>
+          </a:xfrm>
+          <a:prstGeom prst="rect">
+            <a:avLst/>
+          </a:prstGeom>
+          <a:noFill/>
+        </p:spPr>
+        <p:txBody>
+          <a:bodyPr vert="horz" wrap="square" lIns="0" tIns="0" rIns="0" bIns="0" rtlCol="0">
+            <a:noAutofit/>
+          </a:bodyPr>
+          <a:lstStyle/>
+          <a:p>
+            <a:r>
+              <a:rPr lang="en-US" sz="1300">
+                <a:solidFill>
+                  <a:srgbClr val="FFFFFF"/>
+                </a:solidFill>
+                <a:latin typeface="Arial" panose="020B0604020202020204" pitchFamily="34" charset="0"/>
+              </a:rPr>
+              <a:t>origin = meet6CloudService</a:t>
+            </a:r>
+          </a:p>
+        </p:txBody>
+      </p:sp>
+      <p:sp>
+        <p:nvSpPr>
+          <p:cNvPr id="33" name="TextBox 32">
+            <a:extLst>
+              <a:ext uri="{FF2B5EF4-FFF2-40B4-BE49-F238E27FC236}">
+                <a16:creationId xmlns:a16="http://schemas.microsoft.com/office/drawing/2014/main" id="{AF74B100-F150-BE1A-A13C-CBD2FCE7D19B}"/>
+              </a:ext>
+            </a:extLst>
+          </p:cNvPr>
+          <p:cNvSpPr txBox="1"/>
+          <p:nvPr/>
+        </p:nvSpPr>
+        <p:spPr>
+          <a:xfrm>
+            <a:off x="4318000" y="5499100"/>
+            <a:ext cx="3429000" cy="276999"/>
+          </a:xfrm>
+          <a:prstGeom prst="rect">
+            <a:avLst/>
+          </a:prstGeom>
+          <a:noFill/>
+        </p:spPr>
+        <p:txBody>
+          <a:bodyPr vert="horz" wrap="square" lIns="0" tIns="0" rIns="0" bIns="0" rtlCol="0">
+            <a:noAutofit/>
+          </a:bodyPr>
+          <a:lstStyle/>
+          <a:p>
+            <a:r>
+              <a:rPr lang="en-US" sz="1050" b="1">
+                <a:solidFill>
+                  <a:srgbClr val="F37021"/>
+                </a:solidFill>
+                <a:latin typeface="Arial" panose="020B0604020202020204" pitchFamily="34" charset="0"/>
+              </a:rPr>
+              <a:t>HASIL PUSH</a:t>
+            </a:r>
+          </a:p>
+        </p:txBody>
+      </p:sp>
+      <p:sp>
+        <p:nvSpPr>
+          <p:cNvPr id="34" name="TextBox 33">
+            <a:extLst>
+              <a:ext uri="{FF2B5EF4-FFF2-40B4-BE49-F238E27FC236}">
+                <a16:creationId xmlns:a16="http://schemas.microsoft.com/office/drawing/2014/main" id="{B864305D-94C1-CBA2-4912-2EC5B118054C}"/>
+              </a:ext>
+            </a:extLst>
+          </p:cNvPr>
+          <p:cNvSpPr txBox="1"/>
+          <p:nvPr/>
+        </p:nvSpPr>
+        <p:spPr>
+          <a:xfrm>
+            <a:off x="4318000" y="5727700"/>
+            <a:ext cx="3429000" cy="276999"/>
+          </a:xfrm>
+          <a:prstGeom prst="rect">
+            <a:avLst/>
+          </a:prstGeom>
+          <a:noFill/>
+        </p:spPr>
+        <p:txBody>
+          <a:bodyPr vert="horz" wrap="square" lIns="0" tIns="0" rIns="0" bIns="0" rtlCol="0">
+            <a:noAutofit/>
+          </a:bodyPr>
+          <a:lstStyle/>
+          <a:p>
+            <a:r>
+              <a:rPr lang="en-US" sz="1300">
+                <a:solidFill>
+                  <a:srgbClr val="FFFFFF"/>
+                </a:solidFill>
+                <a:latin typeface="Arial" panose="020B0604020202020204" pitchFamily="34" charset="0"/>
+              </a:rPr>
+              <a:t>SHA lokal = remote saat uji</a:t>
+            </a:r>
+          </a:p>
+        </p:txBody>
+      </p:sp>
+      <p:sp>
+        <p:nvSpPr>
+          <p:cNvPr id="35" name="TextBox 34">
+            <a:extLst>
+              <a:ext uri="{FF2B5EF4-FFF2-40B4-BE49-F238E27FC236}">
+                <a16:creationId xmlns:a16="http://schemas.microsoft.com/office/drawing/2014/main" id="{7FEE0EF9-5060-12FC-A5E6-E5367599FF83}"/>
+              </a:ext>
+            </a:extLst>
+          </p:cNvPr>
+          <p:cNvSpPr txBox="1"/>
+          <p:nvPr/>
+        </p:nvSpPr>
+        <p:spPr>
+          <a:xfrm>
+            <a:off x="8001000" y="5499100"/>
+            <a:ext cx="3429000" cy="276999"/>
+          </a:xfrm>
+          <a:prstGeom prst="rect">
+            <a:avLst/>
+          </a:prstGeom>
+          <a:noFill/>
+        </p:spPr>
+        <p:txBody>
+          <a:bodyPr vert="horz" wrap="square" lIns="0" tIns="0" rIns="0" bIns="0" rtlCol="0">
+            <a:noAutofit/>
+          </a:bodyPr>
+          <a:lstStyle/>
+          <a:p>
+            <a:r>
+              <a:rPr lang="en-US" sz="1050" b="1">
+                <a:solidFill>
+                  <a:srgbClr val="F37021"/>
+                </a:solidFill>
+                <a:latin typeface="Arial" panose="020B0604020202020204" pitchFamily="34" charset="0"/>
+              </a:rPr>
+              <a:t>MAHASISWA</a:t>
+            </a:r>
+          </a:p>
+        </p:txBody>
+      </p:sp>
+      <p:sp>
+        <p:nvSpPr>
+          <p:cNvPr id="36" name="TextBox 35">
+            <a:extLst>
+              <a:ext uri="{FF2B5EF4-FFF2-40B4-BE49-F238E27FC236}">
+                <a16:creationId xmlns:a16="http://schemas.microsoft.com/office/drawing/2014/main" id="{B7FAF8FA-E512-3BA5-B85A-15159888CAEB}"/>
+              </a:ext>
+            </a:extLst>
+          </p:cNvPr>
+          <p:cNvSpPr txBox="1"/>
+          <p:nvPr/>
+        </p:nvSpPr>
+        <p:spPr>
+          <a:xfrm>
+            <a:off x="8001000" y="5727700"/>
+            <a:ext cx="3429000" cy="276999"/>
+          </a:xfrm>
+          <a:prstGeom prst="rect">
+            <a:avLst/>
+          </a:prstGeom>
+          <a:noFill/>
+        </p:spPr>
+        <p:txBody>
+          <a:bodyPr vert="horz" wrap="square" lIns="0" tIns="0" rIns="0" bIns="0" rtlCol="0">
+            <a:noAutofit/>
+          </a:bodyPr>
+          <a:lstStyle/>
+          <a:p>
+            <a:r>
+              <a:rPr lang="en-US" sz="1300">
+                <a:solidFill>
+                  <a:srgbClr val="FFFFFF"/>
+                </a:solidFill>
+                <a:latin typeface="Arial" panose="020B0604020202020204" pitchFamily="34" charset="0"/>
+              </a:rPr>
+              <a:t>Ulangi pada repo pribadi</a:t>
+            </a:r>
+          </a:p>
+        </p:txBody>
+      </p:sp>
+      <p:pic>
+        <p:nvPicPr>
+          <p:cNvPr id="37" name="Picture 36" descr="image.png"/>
+          <p:cNvPicPr>
+            <a:picLocks noChangeAspect="1"/>
+          </p:cNvPicPr>
+          <p:nvPr/>
+        </p:nvPicPr>
+        <p:blipFill>
+          <a:blip r:embed="rId4"/>
+          <a:stretch>
+            <a:fillRect/>
+          </a:stretch>
+        </p:blipFill>
+        <p:spPr>
+          <a:xfrm>
+            <a:off x="1369624" y="1490898"/>
+            <a:ext cx="9427351" cy="3723804"/>
+          </a:xfrm>
+          <a:prstGeom prst="rect">
+            <a:avLst/>
+          </a:prstGeom>
+        </p:spPr>
+      </p:pic>
+    </p:spTree>
   </p:cSld>
   <p:clrMapOvr>
     <a:masterClrMapping/>

</xml_diff>

<commit_message>
Align Lab 06 with group project and publish revised theory/practical slides
</commit_message>
<xml_diff>
--- a/slides/LAB06_Cloud_Notes_Compose_Bukti_Live.pptx
+++ b/slides/LAB06_Cloud_Notes_Compose_Bukti_Live.pptx
@@ -2,29 +2,29 @@
 <file path=ppt/presentation.xml><?xml version="1.0" encoding="utf-8"?>
 <p:presentation xmlns:p="http://schemas.openxmlformats.org/presentationml/2006/main">
   <p:sldMasterIdLst>
-    <p:sldMasterId xmlns:r="http://schemas.openxmlformats.org/officeDocument/2006/relationships" id="2147483648" r:id="R881af11a7e2d4423"/>
+    <p:sldMasterId xmlns:r="http://schemas.openxmlformats.org/officeDocument/2006/relationships" id="2147483648" r:id="Ra958c50d233c4729"/>
   </p:sldMasterIdLst>
   <p:notesMasterIdLst>
-    <p:notesMasterId xmlns:r="http://schemas.openxmlformats.org/officeDocument/2006/relationships" r:id="R1a364dcf44484985"/>
+    <p:notesMasterId xmlns:r="http://schemas.openxmlformats.org/officeDocument/2006/relationships" r:id="R1e8330b7ea424072"/>
   </p:notesMasterIdLst>
   <p:sldIdLst>
-    <p:sldId xmlns:r="http://schemas.openxmlformats.org/officeDocument/2006/relationships" id="256" r:id="R177e8860b2e34752"/>
-    <p:sldId xmlns:r="http://schemas.openxmlformats.org/officeDocument/2006/relationships" id="257" r:id="Re06e986150574f41"/>
-    <p:sldId xmlns:r="http://schemas.openxmlformats.org/officeDocument/2006/relationships" id="258" r:id="Rd287d45a39914a34"/>
-    <p:sldId xmlns:r="http://schemas.openxmlformats.org/officeDocument/2006/relationships" id="259" r:id="Rff5a3364401949fc"/>
-    <p:sldId xmlns:r="http://schemas.openxmlformats.org/officeDocument/2006/relationships" id="260" r:id="Rd833c74e5d5f4126"/>
-    <p:sldId xmlns:r="http://schemas.openxmlformats.org/officeDocument/2006/relationships" id="261" r:id="Rcf14c9cf84344ceb"/>
-    <p:sldId xmlns:r="http://schemas.openxmlformats.org/officeDocument/2006/relationships" id="262" r:id="Rbe79ad3933c84551"/>
-    <p:sldId xmlns:r="http://schemas.openxmlformats.org/officeDocument/2006/relationships" id="263" r:id="Rd5ec5c8692fb465b"/>
-    <p:sldId xmlns:r="http://schemas.openxmlformats.org/officeDocument/2006/relationships" id="264" r:id="Rba78d09d9b144b17"/>
-    <p:sldId xmlns:r="http://schemas.openxmlformats.org/officeDocument/2006/relationships" id="265" r:id="Rd496fbe93ff84f3c"/>
-    <p:sldId xmlns:r="http://schemas.openxmlformats.org/officeDocument/2006/relationships" id="266" r:id="R97749994b48f4460"/>
-    <p:sldId xmlns:r="http://schemas.openxmlformats.org/officeDocument/2006/relationships" id="267" r:id="R265f04da6bde44b8"/>
-    <p:sldId xmlns:r="http://schemas.openxmlformats.org/officeDocument/2006/relationships" id="268" r:id="Re6fd785b10584b45"/>
-    <p:sldId xmlns:r="http://schemas.openxmlformats.org/officeDocument/2006/relationships" id="269" r:id="R002af1e61cb841fc"/>
-    <p:sldId xmlns:r="http://schemas.openxmlformats.org/officeDocument/2006/relationships" id="270" r:id="R611ad054f05e466e"/>
-    <p:sldId xmlns:r="http://schemas.openxmlformats.org/officeDocument/2006/relationships" id="271" r:id="R16682a506f9a41db"/>
-    <p:sldId xmlns:r="http://schemas.openxmlformats.org/officeDocument/2006/relationships" id="272" r:id="R38a3c496cc454d9d"/>
+    <p:sldId xmlns:r="http://schemas.openxmlformats.org/officeDocument/2006/relationships" id="256" r:id="Ree3cbbc55fe646ba"/>
+    <p:sldId xmlns:r="http://schemas.openxmlformats.org/officeDocument/2006/relationships" id="257" r:id="R714c580ddeb84ab6"/>
+    <p:sldId xmlns:r="http://schemas.openxmlformats.org/officeDocument/2006/relationships" id="258" r:id="Ra9c90a6eca2541e4"/>
+    <p:sldId xmlns:r="http://schemas.openxmlformats.org/officeDocument/2006/relationships" id="259" r:id="R63ac9779249d4bc0"/>
+    <p:sldId xmlns:r="http://schemas.openxmlformats.org/officeDocument/2006/relationships" id="260" r:id="R8fb5dca026a540c6"/>
+    <p:sldId xmlns:r="http://schemas.openxmlformats.org/officeDocument/2006/relationships" id="261" r:id="Rb9cd24ecd5bf4c55"/>
+    <p:sldId xmlns:r="http://schemas.openxmlformats.org/officeDocument/2006/relationships" id="262" r:id="R1cdffebccd464cd6"/>
+    <p:sldId xmlns:r="http://schemas.openxmlformats.org/officeDocument/2006/relationships" id="263" r:id="Ra747286fa3114325"/>
+    <p:sldId xmlns:r="http://schemas.openxmlformats.org/officeDocument/2006/relationships" id="264" r:id="R65ce6d6ee6c547ff"/>
+    <p:sldId xmlns:r="http://schemas.openxmlformats.org/officeDocument/2006/relationships" id="265" r:id="R7a089dd940a14ded"/>
+    <p:sldId xmlns:r="http://schemas.openxmlformats.org/officeDocument/2006/relationships" id="266" r:id="R6f2bd8f130c04fbc"/>
+    <p:sldId xmlns:r="http://schemas.openxmlformats.org/officeDocument/2006/relationships" id="267" r:id="Rd4a0b7620f0c4571"/>
+    <p:sldId xmlns:r="http://schemas.openxmlformats.org/officeDocument/2006/relationships" id="268" r:id="R3d76f7c02dbf4601"/>
+    <p:sldId xmlns:r="http://schemas.openxmlformats.org/officeDocument/2006/relationships" id="269" r:id="Rf65c981701b84095"/>
+    <p:sldId xmlns:r="http://schemas.openxmlformats.org/officeDocument/2006/relationships" id="270" r:id="R82f38d42bb094191"/>
+    <p:sldId xmlns:r="http://schemas.openxmlformats.org/officeDocument/2006/relationships" id="271" r:id="R27beb09a21e5423d"/>
+    <p:sldId xmlns:r="http://schemas.openxmlformats.org/officeDocument/2006/relationships" id="272" r:id="Ra23214230f094895"/>
   </p:sldIdLst>
   <p:sldSz cx="12192000" cy="6858000"/>
   <p:notesSz cx="6858000" cy="9144000"/>
@@ -1641,7 +1641,7 @@
   </p:cSld>
   <p:clrMap bg1="lt1" tx1="dk1" bg2="lt2" tx2="dk2" accent1="accent1" accent2="accent2" accent3="accent3" accent4="accent4" accent5="accent5" accent6="accent6" hlink="hlink" folHlink="folHlink"/>
   <p:sldLayoutIdLst>
-    <p:sldLayoutId xmlns:r="http://schemas.openxmlformats.org/officeDocument/2006/relationships" id="2147483649" r:id="R27af479a64014b73"/>
+    <p:sldLayoutId xmlns:r="http://schemas.openxmlformats.org/officeDocument/2006/relationships" id="2147483649" r:id="Ra4c20332789e4680"/>
   </p:sldLayoutIdLst>
   <p:hf sldNum="0" hdr="0" ftr="0" dt="0"/>
   <p:txStyles>
@@ -2194,7 +2194,7 @@
     <p:bg>
       <p:bgPr>
         <a:blipFill xmlns:a="http://schemas.openxmlformats.org/drawingml/2006/main" rotWithShape="1">
-          <a:blip xmlns:r="http://schemas.openxmlformats.org/officeDocument/2006/relationships" r:embed="R693fc50d58b2453f">
+          <a:blip xmlns:r="http://schemas.openxmlformats.org/officeDocument/2006/relationships" r:embed="R9de1574cbb3e4ea4">
             <a:lum/>
           </a:blip>
           <a:srcRect l="0" t="0" r="0" b="0"/>
@@ -2222,7 +2222,7 @@
           <p:nvPr/>
         </p:nvPicPr>
         <p:blipFill>
-          <a:blip xmlns:r="http://schemas.openxmlformats.org/officeDocument/2006/relationships" xmlns:a="http://schemas.openxmlformats.org/drawingml/2006/main" r:embed="R518e64fa39044ff0"/>
+          <a:blip xmlns:r="http://schemas.openxmlformats.org/officeDocument/2006/relationships" xmlns:a="http://schemas.openxmlformats.org/drawingml/2006/main" r:embed="Rd83a112de4284e9f"/>
           <a:stretch xmlns:a="http://schemas.openxmlformats.org/drawingml/2006/main">
             <a:fillRect l="0" t="0" r="0" b="0"/>
           </a:stretch>
@@ -2246,7 +2246,7 @@
           <p:nvPr/>
         </p:nvPicPr>
         <p:blipFill>
-          <a:blip xmlns:r="http://schemas.openxmlformats.org/officeDocument/2006/relationships" xmlns:a="http://schemas.openxmlformats.org/drawingml/2006/main" r:embed="Rdaf08f368f6640f4"/>
+          <a:blip xmlns:r="http://schemas.openxmlformats.org/officeDocument/2006/relationships" xmlns:a="http://schemas.openxmlformats.org/drawingml/2006/main" r:embed="R1661fce480604e40"/>
           <a:stretch xmlns:a="http://schemas.openxmlformats.org/drawingml/2006/main">
             <a:fillRect l="0" t="0" r="0" b="0"/>
           </a:stretch>
@@ -2793,7 +2793,7 @@
           <p:nvPr/>
         </p:nvPicPr>
         <p:blipFill>
-          <a:blip xmlns:r="http://schemas.openxmlformats.org/officeDocument/2006/relationships" xmlns:a="http://schemas.openxmlformats.org/drawingml/2006/main" r:embed="Rb48959a13ea047c6"/>
+          <a:blip xmlns:r="http://schemas.openxmlformats.org/officeDocument/2006/relationships" xmlns:a="http://schemas.openxmlformats.org/drawingml/2006/main" r:embed="Rc161cef0ce234392"/>
           <a:stretch xmlns:a="http://schemas.openxmlformats.org/drawingml/2006/main">
             <a:fillRect l="0" t="0" r="0" b="0"/>
           </a:stretch>
@@ -2817,7 +2817,7 @@
           <p:nvPr/>
         </p:nvPicPr>
         <p:blipFill>
-          <a:blip xmlns:r="http://schemas.openxmlformats.org/officeDocument/2006/relationships" xmlns:a="http://schemas.openxmlformats.org/drawingml/2006/main" r:embed="R73f2d393299e4b67"/>
+          <a:blip xmlns:r="http://schemas.openxmlformats.org/officeDocument/2006/relationships" xmlns:a="http://schemas.openxmlformats.org/drawingml/2006/main" r:embed="R7bb5b6decfc145da"/>
           <a:stretch xmlns:a="http://schemas.openxmlformats.org/drawingml/2006/main">
             <a:fillRect l="0" t="0" r="0" b="0"/>
           </a:stretch>
@@ -3057,7 +3057,7 @@
           <p:nvPr/>
         </p:nvPicPr>
         <p:blipFill>
-          <a:blip xmlns:r="http://schemas.openxmlformats.org/officeDocument/2006/relationships" xmlns:a="http://schemas.openxmlformats.org/drawingml/2006/main" r:embed="Rb622216f085446d8"/>
+          <a:blip xmlns:r="http://schemas.openxmlformats.org/officeDocument/2006/relationships" xmlns:a="http://schemas.openxmlformats.org/drawingml/2006/main" r:embed="R02f33edc07b54c22"/>
           <a:stretch xmlns:a="http://schemas.openxmlformats.org/drawingml/2006/main">
             <a:fillRect l="0" t="0" r="0" b="0"/>
           </a:stretch>
@@ -3134,7 +3134,7 @@
           <p:nvPr/>
         </p:nvPicPr>
         <p:blipFill>
-          <a:blip xmlns:r="http://schemas.openxmlformats.org/officeDocument/2006/relationships" xmlns:a="http://schemas.openxmlformats.org/drawingml/2006/main" r:embed="R39e4db289d9e40ae"/>
+          <a:blip xmlns:r="http://schemas.openxmlformats.org/officeDocument/2006/relationships" xmlns:a="http://schemas.openxmlformats.org/drawingml/2006/main" r:embed="R8668304210ea4bfa"/>
           <a:stretch xmlns:a="http://schemas.openxmlformats.org/drawingml/2006/main">
             <a:fillRect l="0" t="0" r="0" b="0"/>
           </a:stretch>
@@ -3211,7 +3211,7 @@
           <p:nvPr/>
         </p:nvPicPr>
         <p:blipFill>
-          <a:blip xmlns:r="http://schemas.openxmlformats.org/officeDocument/2006/relationships" xmlns:a="http://schemas.openxmlformats.org/drawingml/2006/main" r:embed="R396aeafcb3dc48f6"/>
+          <a:blip xmlns:r="http://schemas.openxmlformats.org/officeDocument/2006/relationships" xmlns:a="http://schemas.openxmlformats.org/drawingml/2006/main" r:embed="R10fb3e2ad72f43fd"/>
           <a:stretch xmlns:a="http://schemas.openxmlformats.org/drawingml/2006/main">
             <a:fillRect l="0" t="0" r="0" b="0"/>
           </a:stretch>
@@ -3288,7 +3288,7 @@
           <p:nvPr/>
         </p:nvPicPr>
         <p:blipFill>
-          <a:blip xmlns:r="http://schemas.openxmlformats.org/officeDocument/2006/relationships" xmlns:a="http://schemas.openxmlformats.org/drawingml/2006/main" r:embed="R939f1d0677654daa"/>
+          <a:blip xmlns:r="http://schemas.openxmlformats.org/officeDocument/2006/relationships" xmlns:a="http://schemas.openxmlformats.org/drawingml/2006/main" r:embed="R2c45a24f98824b59"/>
           <a:stretch xmlns:a="http://schemas.openxmlformats.org/drawingml/2006/main">
             <a:fillRect l="0" t="0" r="0" b="0"/>
           </a:stretch>
@@ -3365,7 +3365,7 @@
           <p:nvPr/>
         </p:nvPicPr>
         <p:blipFill>
-          <a:blip xmlns:r="http://schemas.openxmlformats.org/officeDocument/2006/relationships" xmlns:a="http://schemas.openxmlformats.org/drawingml/2006/main" r:embed="Rfb88022a2a864ef4"/>
+          <a:blip xmlns:r="http://schemas.openxmlformats.org/officeDocument/2006/relationships" xmlns:a="http://schemas.openxmlformats.org/drawingml/2006/main" r:embed="R4e337f995240429b"/>
           <a:stretch xmlns:a="http://schemas.openxmlformats.org/drawingml/2006/main">
             <a:fillRect l="0" t="0" r="0" b="0"/>
           </a:stretch>
@@ -3442,7 +3442,7 @@
           <p:nvPr/>
         </p:nvPicPr>
         <p:blipFill>
-          <a:blip xmlns:r="http://schemas.openxmlformats.org/officeDocument/2006/relationships" xmlns:a="http://schemas.openxmlformats.org/drawingml/2006/main" r:embed="Rc1e1e3c9730a47a6"/>
+          <a:blip xmlns:r="http://schemas.openxmlformats.org/officeDocument/2006/relationships" xmlns:a="http://schemas.openxmlformats.org/drawingml/2006/main" r:embed="R380f80992354432f"/>
           <a:stretch xmlns:a="http://schemas.openxmlformats.org/drawingml/2006/main">
             <a:fillRect l="0" t="0" r="0" b="0"/>
           </a:stretch>
@@ -3519,7 +3519,7 @@
           <p:nvPr/>
         </p:nvPicPr>
         <p:blipFill>
-          <a:blip xmlns:r="http://schemas.openxmlformats.org/officeDocument/2006/relationships" xmlns:a="http://schemas.openxmlformats.org/drawingml/2006/main" r:embed="R4a16798a039a4f4d"/>
+          <a:blip xmlns:r="http://schemas.openxmlformats.org/officeDocument/2006/relationships" xmlns:a="http://schemas.openxmlformats.org/drawingml/2006/main" r:embed="R5bea36b7058d4c3b"/>
           <a:stretch xmlns:a="http://schemas.openxmlformats.org/drawingml/2006/main">
             <a:fillRect l="0" t="0" r="0" b="0"/>
           </a:stretch>
@@ -3813,7 +3813,7 @@
           <p:nvPr/>
         </p:nvPicPr>
         <p:blipFill>
-          <a:blip xmlns:r="http://schemas.openxmlformats.org/officeDocument/2006/relationships" xmlns:a="http://schemas.openxmlformats.org/drawingml/2006/main" r:embed="R829fd1a9c2214667"/>
+          <a:blip xmlns:r="http://schemas.openxmlformats.org/officeDocument/2006/relationships" xmlns:a="http://schemas.openxmlformats.org/drawingml/2006/main" r:embed="R0b17a89697e341d9"/>
           <a:stretch xmlns:a="http://schemas.openxmlformats.org/drawingml/2006/main">
             <a:fillRect l="0" t="0" r="0" b="0"/>
           </a:stretch>
@@ -3998,7 +3998,7 @@
           <p:nvPr/>
         </p:nvPicPr>
         <p:blipFill>
-          <a:blip xmlns:r="http://schemas.openxmlformats.org/officeDocument/2006/relationships" xmlns:a="http://schemas.openxmlformats.org/drawingml/2006/main" r:embed="Ra539a7bcfd2e4f7a"/>
+          <a:blip xmlns:r="http://schemas.openxmlformats.org/officeDocument/2006/relationships" xmlns:a="http://schemas.openxmlformats.org/drawingml/2006/main" r:embed="R45dc632de49842cc"/>
           <a:stretch xmlns:a="http://schemas.openxmlformats.org/drawingml/2006/main">
             <a:fillRect l="0" t="0" r="0" b="0"/>
           </a:stretch>
@@ -4022,7 +4022,7 @@
           <p:nvPr/>
         </p:nvPicPr>
         <p:blipFill>
-          <a:blip xmlns:r="http://schemas.openxmlformats.org/officeDocument/2006/relationships" xmlns:a="http://schemas.openxmlformats.org/drawingml/2006/main" r:embed="Re8cf349c2fce4448"/>
+          <a:blip xmlns:r="http://schemas.openxmlformats.org/officeDocument/2006/relationships" xmlns:a="http://schemas.openxmlformats.org/drawingml/2006/main" r:embed="R899d3144cadf429b"/>
           <a:stretch xmlns:a="http://schemas.openxmlformats.org/drawingml/2006/main">
             <a:fillRect l="0" t="0" r="0" b="0"/>
           </a:stretch>
@@ -4954,7 +4954,7 @@
           <p:nvPr/>
         </p:nvPicPr>
         <p:blipFill>
-          <a:blip xmlns:r="http://schemas.openxmlformats.org/officeDocument/2006/relationships" xmlns:a="http://schemas.openxmlformats.org/drawingml/2006/main" r:embed="R8185856816d54834"/>
+          <a:blip xmlns:r="http://schemas.openxmlformats.org/officeDocument/2006/relationships" xmlns:a="http://schemas.openxmlformats.org/drawingml/2006/main" r:embed="R70714c301a774446"/>
           <a:stretch xmlns:a="http://schemas.openxmlformats.org/drawingml/2006/main">
             <a:fillRect l="0" t="0" r="0" b="0"/>
           </a:stretch>
@@ -4978,7 +4978,7 @@
           <p:nvPr/>
         </p:nvPicPr>
         <p:blipFill>
-          <a:blip xmlns:r="http://schemas.openxmlformats.org/officeDocument/2006/relationships" xmlns:a="http://schemas.openxmlformats.org/drawingml/2006/main" r:embed="R245dff8fcd264232"/>
+          <a:blip xmlns:r="http://schemas.openxmlformats.org/officeDocument/2006/relationships" xmlns:a="http://schemas.openxmlformats.org/drawingml/2006/main" r:embed="R2d0523fb27d54ec1"/>
           <a:stretch xmlns:a="http://schemas.openxmlformats.org/drawingml/2006/main">
             <a:fillRect l="0" t="0" r="0" b="0"/>
           </a:stretch>
@@ -5218,7 +5218,7 @@
           <p:nvPr/>
         </p:nvPicPr>
         <p:blipFill>
-          <a:blip xmlns:r="http://schemas.openxmlformats.org/officeDocument/2006/relationships" xmlns:a="http://schemas.openxmlformats.org/drawingml/2006/main" r:embed="R6087fbf524154377"/>
+          <a:blip xmlns:r="http://schemas.openxmlformats.org/officeDocument/2006/relationships" xmlns:a="http://schemas.openxmlformats.org/drawingml/2006/main" r:embed="Re9726ebb11af409a"/>
           <a:stretch xmlns:a="http://schemas.openxmlformats.org/drawingml/2006/main">
             <a:fillRect l="0" t="0" r="0" b="0"/>
           </a:stretch>
@@ -5295,7 +5295,7 @@
           <p:nvPr/>
         </p:nvPicPr>
         <p:blipFill>
-          <a:blip xmlns:r="http://schemas.openxmlformats.org/officeDocument/2006/relationships" xmlns:a="http://schemas.openxmlformats.org/drawingml/2006/main" r:embed="Re2aed57e3ea146f5"/>
+          <a:blip xmlns:r="http://schemas.openxmlformats.org/officeDocument/2006/relationships" xmlns:a="http://schemas.openxmlformats.org/drawingml/2006/main" r:embed="R3f13d7f9df8b422a"/>
           <a:stretch xmlns:a="http://schemas.openxmlformats.org/drawingml/2006/main">
             <a:fillRect l="0" t="0" r="0" b="0"/>
           </a:stretch>
@@ -5372,7 +5372,7 @@
           <p:nvPr/>
         </p:nvPicPr>
         <p:blipFill>
-          <a:blip xmlns:r="http://schemas.openxmlformats.org/officeDocument/2006/relationships" xmlns:a="http://schemas.openxmlformats.org/drawingml/2006/main" r:embed="R7d0f65dad1ea4301"/>
+          <a:blip xmlns:r="http://schemas.openxmlformats.org/officeDocument/2006/relationships" xmlns:a="http://schemas.openxmlformats.org/drawingml/2006/main" r:embed="R86ea08f6c49a4166"/>
           <a:stretch xmlns:a="http://schemas.openxmlformats.org/drawingml/2006/main">
             <a:fillRect l="0" t="0" r="0" b="0"/>
           </a:stretch>
@@ -5449,7 +5449,7 @@
           <p:nvPr/>
         </p:nvPicPr>
         <p:blipFill>
-          <a:blip xmlns:r="http://schemas.openxmlformats.org/officeDocument/2006/relationships" xmlns:a="http://schemas.openxmlformats.org/drawingml/2006/main" r:embed="R22032dba75f449a0"/>
+          <a:blip xmlns:r="http://schemas.openxmlformats.org/officeDocument/2006/relationships" xmlns:a="http://schemas.openxmlformats.org/drawingml/2006/main" r:embed="R8fa968c296cb443d"/>
           <a:stretch xmlns:a="http://schemas.openxmlformats.org/drawingml/2006/main">
             <a:fillRect l="0" t="0" r="0" b="0"/>
           </a:stretch>
@@ -5526,7 +5526,7 @@
           <p:nvPr/>
         </p:nvPicPr>
         <p:blipFill>
-          <a:blip xmlns:r="http://schemas.openxmlformats.org/officeDocument/2006/relationships" xmlns:a="http://schemas.openxmlformats.org/drawingml/2006/main" r:embed="Rce2c221d89834ab0"/>
+          <a:blip xmlns:r="http://schemas.openxmlformats.org/officeDocument/2006/relationships" xmlns:a="http://schemas.openxmlformats.org/drawingml/2006/main" r:embed="Rb897be1b57574821"/>
           <a:stretch xmlns:a="http://schemas.openxmlformats.org/drawingml/2006/main">
             <a:fillRect l="0" t="0" r="0" b="0"/>
           </a:stretch>
@@ -5603,7 +5603,7 @@
           <p:nvPr/>
         </p:nvPicPr>
         <p:blipFill>
-          <a:blip xmlns:r="http://schemas.openxmlformats.org/officeDocument/2006/relationships" xmlns:a="http://schemas.openxmlformats.org/drawingml/2006/main" r:embed="Rc0d9ce13121e40f1"/>
+          <a:blip xmlns:r="http://schemas.openxmlformats.org/officeDocument/2006/relationships" xmlns:a="http://schemas.openxmlformats.org/drawingml/2006/main" r:embed="R3e55d31c3e634751"/>
           <a:stretch xmlns:a="http://schemas.openxmlformats.org/drawingml/2006/main">
             <a:fillRect l="0" t="0" r="0" b="0"/>
           </a:stretch>
@@ -5680,7 +5680,7 @@
           <p:nvPr/>
         </p:nvPicPr>
         <p:blipFill>
-          <a:blip xmlns:r="http://schemas.openxmlformats.org/officeDocument/2006/relationships" xmlns:a="http://schemas.openxmlformats.org/drawingml/2006/main" r:embed="Re7399dddda9a45cf"/>
+          <a:blip xmlns:r="http://schemas.openxmlformats.org/officeDocument/2006/relationships" xmlns:a="http://schemas.openxmlformats.org/drawingml/2006/main" r:embed="R54bf8a0fa2f74659"/>
           <a:stretch xmlns:a="http://schemas.openxmlformats.org/drawingml/2006/main">
             <a:fillRect l="0" t="0" r="0" b="0"/>
           </a:stretch>
@@ -5974,7 +5974,7 @@
           <p:nvPr/>
         </p:nvPicPr>
         <p:blipFill>
-          <a:blip xmlns:r="http://schemas.openxmlformats.org/officeDocument/2006/relationships" xmlns:a="http://schemas.openxmlformats.org/drawingml/2006/main" r:embed="R017cca41761a4122"/>
+          <a:blip xmlns:r="http://schemas.openxmlformats.org/officeDocument/2006/relationships" xmlns:a="http://schemas.openxmlformats.org/drawingml/2006/main" r:embed="Rb4db1586dbfc43e2"/>
           <a:stretch xmlns:a="http://schemas.openxmlformats.org/drawingml/2006/main">
             <a:fillRect l="0" t="0" r="0" b="0"/>
           </a:stretch>
@@ -6159,7 +6159,7 @@
           <p:nvPr/>
         </p:nvPicPr>
         <p:blipFill>
-          <a:blip xmlns:r="http://schemas.openxmlformats.org/officeDocument/2006/relationships" xmlns:a="http://schemas.openxmlformats.org/drawingml/2006/main" r:embed="R82b6dafaf4e94851"/>
+          <a:blip xmlns:r="http://schemas.openxmlformats.org/officeDocument/2006/relationships" xmlns:a="http://schemas.openxmlformats.org/drawingml/2006/main" r:embed="Rdc4938a323cf4f2c"/>
           <a:stretch xmlns:a="http://schemas.openxmlformats.org/drawingml/2006/main">
             <a:fillRect l="0" t="0" r="0" b="0"/>
           </a:stretch>
@@ -6183,7 +6183,7 @@
           <p:nvPr/>
         </p:nvPicPr>
         <p:blipFill>
-          <a:blip xmlns:r="http://schemas.openxmlformats.org/officeDocument/2006/relationships" xmlns:a="http://schemas.openxmlformats.org/drawingml/2006/main" r:embed="R93205b7189344004"/>
+          <a:blip xmlns:r="http://schemas.openxmlformats.org/officeDocument/2006/relationships" xmlns:a="http://schemas.openxmlformats.org/drawingml/2006/main" r:embed="R97fd6dea9bc04c27"/>
           <a:stretch xmlns:a="http://schemas.openxmlformats.org/drawingml/2006/main">
             <a:fillRect l="0" t="0" r="0" b="0"/>
           </a:stretch>
@@ -7113,7 +7113,7 @@
           <p:nvPr/>
         </p:nvPicPr>
         <p:blipFill>
-          <a:blip xmlns:r="http://schemas.openxmlformats.org/officeDocument/2006/relationships" xmlns:a="http://schemas.openxmlformats.org/drawingml/2006/main" r:embed="Rfff91ab06282476d"/>
+          <a:blip xmlns:r="http://schemas.openxmlformats.org/officeDocument/2006/relationships" xmlns:a="http://schemas.openxmlformats.org/drawingml/2006/main" r:embed="Ra29cb509bd584769"/>
           <a:stretch xmlns:a="http://schemas.openxmlformats.org/drawingml/2006/main">
             <a:fillRect l="0" t="0" r="0" b="0"/>
           </a:stretch>
@@ -7137,7 +7137,7 @@
           <p:nvPr/>
         </p:nvPicPr>
         <p:blipFill>
-          <a:blip xmlns:r="http://schemas.openxmlformats.org/officeDocument/2006/relationships" xmlns:a="http://schemas.openxmlformats.org/drawingml/2006/main" r:embed="R123aeb816c5e4e84"/>
+          <a:blip xmlns:r="http://schemas.openxmlformats.org/officeDocument/2006/relationships" xmlns:a="http://schemas.openxmlformats.org/drawingml/2006/main" r:embed="Rfd4e934d79544bb0"/>
           <a:stretch xmlns:a="http://schemas.openxmlformats.org/drawingml/2006/main">
             <a:fillRect l="0" t="0" r="0" b="0"/>
           </a:stretch>
@@ -8054,7 +8054,7 @@
           <p:nvPr/>
         </p:nvPicPr>
         <p:blipFill>
-          <a:blip xmlns:r="http://schemas.openxmlformats.org/officeDocument/2006/relationships" xmlns:a="http://schemas.openxmlformats.org/drawingml/2006/main" r:embed="R86cc730eeb6c4439"/>
+          <a:blip xmlns:r="http://schemas.openxmlformats.org/officeDocument/2006/relationships" xmlns:a="http://schemas.openxmlformats.org/drawingml/2006/main" r:embed="R3959449be8324ff4"/>
           <a:stretch xmlns:a="http://schemas.openxmlformats.org/drawingml/2006/main">
             <a:fillRect l="0" t="0" r="0" b="0"/>
           </a:stretch>
@@ -8078,7 +8078,7 @@
           <p:nvPr/>
         </p:nvPicPr>
         <p:blipFill>
-          <a:blip xmlns:r="http://schemas.openxmlformats.org/officeDocument/2006/relationships" xmlns:a="http://schemas.openxmlformats.org/drawingml/2006/main" r:embed="R88773f5f020a4795"/>
+          <a:blip xmlns:r="http://schemas.openxmlformats.org/officeDocument/2006/relationships" xmlns:a="http://schemas.openxmlformats.org/drawingml/2006/main" r:embed="Redf4d47d86bb4d14"/>
           <a:stretch xmlns:a="http://schemas.openxmlformats.org/drawingml/2006/main">
             <a:fillRect l="0" t="0" r="0" b="0"/>
           </a:stretch>
@@ -8604,7 +8604,7 @@
           <p:nvPr/>
         </p:nvPicPr>
         <p:blipFill>
-          <a:blip xmlns:r="http://schemas.openxmlformats.org/officeDocument/2006/relationships" xmlns:a="http://schemas.openxmlformats.org/drawingml/2006/main" r:embed="R15566e026982410b"/>
+          <a:blip xmlns:r="http://schemas.openxmlformats.org/officeDocument/2006/relationships" xmlns:a="http://schemas.openxmlformats.org/drawingml/2006/main" r:embed="R8115c8ddf1824ed0"/>
           <a:stretch xmlns:a="http://schemas.openxmlformats.org/drawingml/2006/main">
             <a:fillRect l="0" t="0" r="0" b="0"/>
           </a:stretch>
@@ -8775,7 +8775,7 @@
           <p:nvPr/>
         </p:nvPicPr>
         <p:blipFill>
-          <a:blip xmlns:r="http://schemas.openxmlformats.org/officeDocument/2006/relationships" xmlns:a="http://schemas.openxmlformats.org/drawingml/2006/main" r:embed="R6fa6819aaf074c3d"/>
+          <a:blip xmlns:r="http://schemas.openxmlformats.org/officeDocument/2006/relationships" xmlns:a="http://schemas.openxmlformats.org/drawingml/2006/main" r:embed="Rdba0596f52934c7f"/>
           <a:stretch xmlns:a="http://schemas.openxmlformats.org/drawingml/2006/main">
             <a:fillRect l="0" t="0" r="0" b="0"/>
           </a:stretch>
@@ -8799,7 +8799,7 @@
           <p:nvPr/>
         </p:nvPicPr>
         <p:blipFill>
-          <a:blip xmlns:r="http://schemas.openxmlformats.org/officeDocument/2006/relationships" xmlns:a="http://schemas.openxmlformats.org/drawingml/2006/main" r:embed="R99138e24b1574ef5"/>
+          <a:blip xmlns:r="http://schemas.openxmlformats.org/officeDocument/2006/relationships" xmlns:a="http://schemas.openxmlformats.org/drawingml/2006/main" r:embed="R662448878a034e37"/>
           <a:stretch xmlns:a="http://schemas.openxmlformats.org/drawingml/2006/main">
             <a:fillRect l="0" t="0" r="0" b="0"/>
           </a:stretch>
@@ -9325,7 +9325,7 @@
           <p:nvPr/>
         </p:nvPicPr>
         <p:blipFill>
-          <a:blip xmlns:r="http://schemas.openxmlformats.org/officeDocument/2006/relationships" xmlns:a="http://schemas.openxmlformats.org/drawingml/2006/main" r:embed="Rceacd072533e405f"/>
+          <a:blip xmlns:r="http://schemas.openxmlformats.org/officeDocument/2006/relationships" xmlns:a="http://schemas.openxmlformats.org/drawingml/2006/main" r:embed="R3c548b42048a4a28"/>
           <a:stretch xmlns:a="http://schemas.openxmlformats.org/drawingml/2006/main">
             <a:fillRect l="0" t="0" r="0" b="0"/>
           </a:stretch>
@@ -9496,7 +9496,7 @@
           <p:nvPr/>
         </p:nvPicPr>
         <p:blipFill>
-          <a:blip xmlns:r="http://schemas.openxmlformats.org/officeDocument/2006/relationships" xmlns:a="http://schemas.openxmlformats.org/drawingml/2006/main" r:embed="Rb14488d2052d4477"/>
+          <a:blip xmlns:r="http://schemas.openxmlformats.org/officeDocument/2006/relationships" xmlns:a="http://schemas.openxmlformats.org/drawingml/2006/main" r:embed="R6df255310642432f"/>
           <a:stretch xmlns:a="http://schemas.openxmlformats.org/drawingml/2006/main">
             <a:fillRect l="0" t="0" r="0" b="0"/>
           </a:stretch>
@@ -9520,7 +9520,7 @@
           <p:nvPr/>
         </p:nvPicPr>
         <p:blipFill>
-          <a:blip xmlns:r="http://schemas.openxmlformats.org/officeDocument/2006/relationships" xmlns:a="http://schemas.openxmlformats.org/drawingml/2006/main" r:embed="Re57afe579d8d46e9"/>
+          <a:blip xmlns:r="http://schemas.openxmlformats.org/officeDocument/2006/relationships" xmlns:a="http://schemas.openxmlformats.org/drawingml/2006/main" r:embed="Rcd60392be7184cdb"/>
           <a:stretch xmlns:a="http://schemas.openxmlformats.org/drawingml/2006/main">
             <a:fillRect l="0" t="0" r="0" b="0"/>
           </a:stretch>
@@ -10046,7 +10046,7 @@
           <p:nvPr/>
         </p:nvPicPr>
         <p:blipFill>
-          <a:blip xmlns:r="http://schemas.openxmlformats.org/officeDocument/2006/relationships" xmlns:a="http://schemas.openxmlformats.org/drawingml/2006/main" r:embed="Rcd4b67e1d465483e"/>
+          <a:blip xmlns:r="http://schemas.openxmlformats.org/officeDocument/2006/relationships" xmlns:a="http://schemas.openxmlformats.org/drawingml/2006/main" r:embed="R11b0e3960a4c4bb6"/>
           <a:stretch xmlns:a="http://schemas.openxmlformats.org/drawingml/2006/main">
             <a:fillRect l="0" t="0" r="0" b="0"/>
           </a:stretch>
@@ -10231,7 +10231,7 @@
           <p:nvPr/>
         </p:nvPicPr>
         <p:blipFill>
-          <a:blip xmlns:r="http://schemas.openxmlformats.org/officeDocument/2006/relationships" xmlns:a="http://schemas.openxmlformats.org/drawingml/2006/main" r:embed="Rd878fc0ba0304f70"/>
+          <a:blip xmlns:r="http://schemas.openxmlformats.org/officeDocument/2006/relationships" xmlns:a="http://schemas.openxmlformats.org/drawingml/2006/main" r:embed="R2d38faca42194805"/>
           <a:stretch xmlns:a="http://schemas.openxmlformats.org/drawingml/2006/main">
             <a:fillRect l="0" t="0" r="0" b="0"/>
           </a:stretch>
@@ -10255,7 +10255,7 @@
           <p:nvPr/>
         </p:nvPicPr>
         <p:blipFill>
-          <a:blip xmlns:r="http://schemas.openxmlformats.org/officeDocument/2006/relationships" xmlns:a="http://schemas.openxmlformats.org/drawingml/2006/main" r:embed="R443ddda635b247bc"/>
+          <a:blip xmlns:r="http://schemas.openxmlformats.org/officeDocument/2006/relationships" xmlns:a="http://schemas.openxmlformats.org/drawingml/2006/main" r:embed="Rd7df3f2494354db0"/>
           <a:stretch xmlns:a="http://schemas.openxmlformats.org/drawingml/2006/main">
             <a:fillRect l="0" t="0" r="0" b="0"/>
           </a:stretch>
@@ -10524,7 +10524,7 @@
           <p:nvPr/>
         </p:nvPicPr>
         <p:blipFill>
-          <a:blip xmlns:r="http://schemas.openxmlformats.org/officeDocument/2006/relationships" xmlns:a="http://schemas.openxmlformats.org/drawingml/2006/main" r:embed="Ra5b88d8b87cb4282"/>
+          <a:blip xmlns:r="http://schemas.openxmlformats.org/officeDocument/2006/relationships" xmlns:a="http://schemas.openxmlformats.org/drawingml/2006/main" r:embed="R646c646fca2149fc"/>
           <a:stretch xmlns:a="http://schemas.openxmlformats.org/drawingml/2006/main">
             <a:fillRect l="0" t="0" r="0" b="0"/>
           </a:stretch>
@@ -10594,7 +10594,7 @@
           <p:nvPr/>
         </p:nvPicPr>
         <p:blipFill>
-          <a:blip xmlns:r="http://schemas.openxmlformats.org/officeDocument/2006/relationships" xmlns:a="http://schemas.openxmlformats.org/drawingml/2006/main" r:embed="R23335261b49d438b"/>
+          <a:blip xmlns:r="http://schemas.openxmlformats.org/officeDocument/2006/relationships" xmlns:a="http://schemas.openxmlformats.org/drawingml/2006/main" r:embed="Re0e6ccc413dc488f"/>
           <a:stretch xmlns:a="http://schemas.openxmlformats.org/drawingml/2006/main">
             <a:fillRect l="0" t="0" r="0" b="0"/>
           </a:stretch>
@@ -10664,7 +10664,7 @@
           <p:nvPr/>
         </p:nvPicPr>
         <p:blipFill>
-          <a:blip xmlns:r="http://schemas.openxmlformats.org/officeDocument/2006/relationships" xmlns:a="http://schemas.openxmlformats.org/drawingml/2006/main" r:embed="R63a51685ef5842f4"/>
+          <a:blip xmlns:r="http://schemas.openxmlformats.org/officeDocument/2006/relationships" xmlns:a="http://schemas.openxmlformats.org/drawingml/2006/main" r:embed="Rb97dc3514cc044da"/>
           <a:stretch xmlns:a="http://schemas.openxmlformats.org/drawingml/2006/main">
             <a:fillRect l="0" t="0" r="0" b="0"/>
           </a:stretch>
@@ -10734,7 +10734,7 @@
           <p:nvPr/>
         </p:nvPicPr>
         <p:blipFill>
-          <a:blip xmlns:r="http://schemas.openxmlformats.org/officeDocument/2006/relationships" xmlns:a="http://schemas.openxmlformats.org/drawingml/2006/main" r:embed="Rd0358a6360a84ae2"/>
+          <a:blip xmlns:r="http://schemas.openxmlformats.org/officeDocument/2006/relationships" xmlns:a="http://schemas.openxmlformats.org/drawingml/2006/main" r:embed="R535eea19a8ed462a"/>
           <a:stretch xmlns:a="http://schemas.openxmlformats.org/drawingml/2006/main">
             <a:fillRect l="0" t="0" r="0" b="0"/>
           </a:stretch>
@@ -10804,7 +10804,7 @@
           <p:nvPr/>
         </p:nvPicPr>
         <p:blipFill>
-          <a:blip xmlns:r="http://schemas.openxmlformats.org/officeDocument/2006/relationships" xmlns:a="http://schemas.openxmlformats.org/drawingml/2006/main" r:embed="R805431f0c906473e"/>
+          <a:blip xmlns:r="http://schemas.openxmlformats.org/officeDocument/2006/relationships" xmlns:a="http://schemas.openxmlformats.org/drawingml/2006/main" r:embed="Rbe1838032b264b77"/>
           <a:stretch xmlns:a="http://schemas.openxmlformats.org/drawingml/2006/main">
             <a:fillRect l="0" t="0" r="0" b="0"/>
           </a:stretch>
@@ -10874,7 +10874,7 @@
           <p:nvPr/>
         </p:nvPicPr>
         <p:blipFill>
-          <a:blip xmlns:r="http://schemas.openxmlformats.org/officeDocument/2006/relationships" xmlns:a="http://schemas.openxmlformats.org/drawingml/2006/main" r:embed="R8d1365030c55494e"/>
+          <a:blip xmlns:r="http://schemas.openxmlformats.org/officeDocument/2006/relationships" xmlns:a="http://schemas.openxmlformats.org/drawingml/2006/main" r:embed="R4c7a088321dd499e"/>
           <a:stretch xmlns:a="http://schemas.openxmlformats.org/drawingml/2006/main">
             <a:fillRect l="0" t="0" r="0" b="0"/>
           </a:stretch>
@@ -10944,7 +10944,7 @@
           <p:nvPr/>
         </p:nvPicPr>
         <p:blipFill>
-          <a:blip xmlns:r="http://schemas.openxmlformats.org/officeDocument/2006/relationships" xmlns:a="http://schemas.openxmlformats.org/drawingml/2006/main" r:embed="R5f9c569bb1894cd4"/>
+          <a:blip xmlns:r="http://schemas.openxmlformats.org/officeDocument/2006/relationships" xmlns:a="http://schemas.openxmlformats.org/drawingml/2006/main" r:embed="Rb9086e52cbe14b8b"/>
           <a:stretch xmlns:a="http://schemas.openxmlformats.org/drawingml/2006/main">
             <a:fillRect l="0" t="0" r="0" b="0"/>
           </a:stretch>
@@ -11085,7 +11085,7 @@
                 <a:ea typeface="Calibri"/>
                 <a:cs typeface="Calibri"/>
               </a:rPr>
-              <a:t>BUKTI YANG DIKUMPULKAN</a:t>
+              <a:t>PROYEK KELOMPOK</a:t>
             </a:r>
           </a:p>
           <a:p xmlns:a="http://schemas.openxmlformats.org/drawingml/2006/main">
@@ -11114,7 +11114,7 @@
                 <a:ea typeface="Calibri"/>
                 <a:cs typeface="Calibri"/>
               </a:rPr>
-              <a:t>Hasil mesin sendiri</a:t>
+              <a:t>Tim 3 orang</a:t>
             </a:r>
             <a:endParaRPr sz="1100"/>
           </a:p>
@@ -11163,7 +11163,7 @@
                 <a:ea typeface="Calibri"/>
                 <a:cs typeface="Calibri"/>
               </a:rPr>
-              <a:t>1. Compose dan API Cloud Notes</a:t>
+              <a:t>Compose menyatukan API, DB, dan cache proyek</a:t>
             </a:r>
           </a:p>
           <a:p xmlns:a="http://schemas.openxmlformats.org/drawingml/2006/main">
@@ -11182,7 +11182,7 @@
                 <a:ea typeface="Calibri"/>
                 <a:cs typeface="Calibri"/>
               </a:rPr>
-              <a:t>2. Bukti tiga service sehat</a:t>
+              <a:t>Uji health serta data persisten</a:t>
             </a:r>
           </a:p>
           <a:p xmlns:a="http://schemas.openxmlformats.org/drawingml/2006/main">
@@ -11201,7 +11201,7 @@
                 <a:ea typeface="Calibri"/>
                 <a:cs typeface="Calibri"/>
               </a:rPr>
-              <a:t>3. MISS/HIT, SQL, persistensi</a:t>
+              <a:t>Simpan bukti bila berguna</a:t>
             </a:r>
           </a:p>
           <a:p xmlns:a="http://schemas.openxmlformats.org/drawingml/2006/main">
@@ -11220,7 +11220,7 @@
                 <a:ea typeface="Calibri"/>
                 <a:cs typeface="Calibri"/>
               </a:rPr>
-              <a:t>4. Commit tanpa password asli</a:t>
+              <a:t>Minggu 7 dan 14; tanpa nilai Lab 06</a:t>
             </a:r>
             <a:endParaRPr sz="1700"/>
           </a:p>
@@ -11482,7 +11482,7 @@
           <p:nvPr/>
         </p:nvPicPr>
         <p:blipFill>
-          <a:blip xmlns:r="http://schemas.openxmlformats.org/officeDocument/2006/relationships" xmlns:a="http://schemas.openxmlformats.org/drawingml/2006/main" r:embed="R689e8b368bed4559"/>
+          <a:blip xmlns:r="http://schemas.openxmlformats.org/officeDocument/2006/relationships" xmlns:a="http://schemas.openxmlformats.org/drawingml/2006/main" r:embed="Rb3b158ff7a4c423b"/>
           <a:stretch xmlns:a="http://schemas.openxmlformats.org/drawingml/2006/main">
             <a:fillRect l="0" t="0" r="0" b="0"/>
           </a:stretch>
@@ -11506,7 +11506,7 @@
           <p:nvPr/>
         </p:nvPicPr>
         <p:blipFill>
-          <a:blip xmlns:r="http://schemas.openxmlformats.org/officeDocument/2006/relationships" xmlns:a="http://schemas.openxmlformats.org/drawingml/2006/main" r:embed="R0cd6c2a169d347a4"/>
+          <a:blip xmlns:r="http://schemas.openxmlformats.org/officeDocument/2006/relationships" xmlns:a="http://schemas.openxmlformats.org/drawingml/2006/main" r:embed="R7a4d611291954d76"/>
           <a:stretch xmlns:a="http://schemas.openxmlformats.org/drawingml/2006/main">
             <a:fillRect l="0" t="0" r="0" b="0"/>
           </a:stretch>
@@ -12436,7 +12436,7 @@
           <p:nvPr/>
         </p:nvPicPr>
         <p:blipFill>
-          <a:blip xmlns:r="http://schemas.openxmlformats.org/officeDocument/2006/relationships" xmlns:a="http://schemas.openxmlformats.org/drawingml/2006/main" r:embed="Ra918a0abae3a470f"/>
+          <a:blip xmlns:r="http://schemas.openxmlformats.org/officeDocument/2006/relationships" xmlns:a="http://schemas.openxmlformats.org/drawingml/2006/main" r:embed="R2cac944a6e3b47c7"/>
           <a:stretch xmlns:a="http://schemas.openxmlformats.org/drawingml/2006/main">
             <a:fillRect l="0" t="0" r="0" b="0"/>
           </a:stretch>
@@ -12460,7 +12460,7 @@
           <p:nvPr/>
         </p:nvPicPr>
         <p:blipFill>
-          <a:blip xmlns:r="http://schemas.openxmlformats.org/officeDocument/2006/relationships" xmlns:a="http://schemas.openxmlformats.org/drawingml/2006/main" r:embed="R27b0cb52d12e4446"/>
+          <a:blip xmlns:r="http://schemas.openxmlformats.org/officeDocument/2006/relationships" xmlns:a="http://schemas.openxmlformats.org/drawingml/2006/main" r:embed="R0d162726d80f4ef5"/>
           <a:stretch xmlns:a="http://schemas.openxmlformats.org/drawingml/2006/main">
             <a:fillRect l="0" t="0" r="0" b="0"/>
           </a:stretch>
@@ -12700,7 +12700,7 @@
           <p:nvPr/>
         </p:nvPicPr>
         <p:blipFill>
-          <a:blip xmlns:r="http://schemas.openxmlformats.org/officeDocument/2006/relationships" xmlns:a="http://schemas.openxmlformats.org/drawingml/2006/main" r:embed="R58b6858c9e4e46e6"/>
+          <a:blip xmlns:r="http://schemas.openxmlformats.org/officeDocument/2006/relationships" xmlns:a="http://schemas.openxmlformats.org/drawingml/2006/main" r:embed="R2df5049094604b19"/>
           <a:stretch xmlns:a="http://schemas.openxmlformats.org/drawingml/2006/main">
             <a:fillRect l="0" t="0" r="0" b="0"/>
           </a:stretch>
@@ -12777,7 +12777,7 @@
           <p:nvPr/>
         </p:nvPicPr>
         <p:blipFill>
-          <a:blip xmlns:r="http://schemas.openxmlformats.org/officeDocument/2006/relationships" xmlns:a="http://schemas.openxmlformats.org/drawingml/2006/main" r:embed="R489736650ee349ab"/>
+          <a:blip xmlns:r="http://schemas.openxmlformats.org/officeDocument/2006/relationships" xmlns:a="http://schemas.openxmlformats.org/drawingml/2006/main" r:embed="R25abba9fc8954da0"/>
           <a:stretch xmlns:a="http://schemas.openxmlformats.org/drawingml/2006/main">
             <a:fillRect l="0" t="0" r="0" b="0"/>
           </a:stretch>
@@ -12854,7 +12854,7 @@
           <p:nvPr/>
         </p:nvPicPr>
         <p:blipFill>
-          <a:blip xmlns:r="http://schemas.openxmlformats.org/officeDocument/2006/relationships" xmlns:a="http://schemas.openxmlformats.org/drawingml/2006/main" r:embed="R881e4a253ea74383"/>
+          <a:blip xmlns:r="http://schemas.openxmlformats.org/officeDocument/2006/relationships" xmlns:a="http://schemas.openxmlformats.org/drawingml/2006/main" r:embed="Rbc8567aeb11342de"/>
           <a:stretch xmlns:a="http://schemas.openxmlformats.org/drawingml/2006/main">
             <a:fillRect l="0" t="0" r="0" b="0"/>
           </a:stretch>
@@ -12931,7 +12931,7 @@
           <p:nvPr/>
         </p:nvPicPr>
         <p:blipFill>
-          <a:blip xmlns:r="http://schemas.openxmlformats.org/officeDocument/2006/relationships" xmlns:a="http://schemas.openxmlformats.org/drawingml/2006/main" r:embed="R536117099d124c81"/>
+          <a:blip xmlns:r="http://schemas.openxmlformats.org/officeDocument/2006/relationships" xmlns:a="http://schemas.openxmlformats.org/drawingml/2006/main" r:embed="R00f77d62f2a849fe"/>
           <a:stretch xmlns:a="http://schemas.openxmlformats.org/drawingml/2006/main">
             <a:fillRect l="0" t="0" r="0" b="0"/>
           </a:stretch>
@@ -13008,7 +13008,7 @@
           <p:nvPr/>
         </p:nvPicPr>
         <p:blipFill>
-          <a:blip xmlns:r="http://schemas.openxmlformats.org/officeDocument/2006/relationships" xmlns:a="http://schemas.openxmlformats.org/drawingml/2006/main" r:embed="Rc5ab0aac74ca4e51"/>
+          <a:blip xmlns:r="http://schemas.openxmlformats.org/officeDocument/2006/relationships" xmlns:a="http://schemas.openxmlformats.org/drawingml/2006/main" r:embed="Rb25d6d1186444b6a"/>
           <a:stretch xmlns:a="http://schemas.openxmlformats.org/drawingml/2006/main">
             <a:fillRect l="0" t="0" r="0" b="0"/>
           </a:stretch>
@@ -13085,7 +13085,7 @@
           <p:nvPr/>
         </p:nvPicPr>
         <p:blipFill>
-          <a:blip xmlns:r="http://schemas.openxmlformats.org/officeDocument/2006/relationships" xmlns:a="http://schemas.openxmlformats.org/drawingml/2006/main" r:embed="Rddc8aad84dfb4fd1"/>
+          <a:blip xmlns:r="http://schemas.openxmlformats.org/officeDocument/2006/relationships" xmlns:a="http://schemas.openxmlformats.org/drawingml/2006/main" r:embed="R8ed8a2b4828d48ac"/>
           <a:stretch xmlns:a="http://schemas.openxmlformats.org/drawingml/2006/main">
             <a:fillRect l="0" t="0" r="0" b="0"/>
           </a:stretch>
@@ -13162,7 +13162,7 @@
           <p:nvPr/>
         </p:nvPicPr>
         <p:blipFill>
-          <a:blip xmlns:r="http://schemas.openxmlformats.org/officeDocument/2006/relationships" xmlns:a="http://schemas.openxmlformats.org/drawingml/2006/main" r:embed="R22178c8389744681"/>
+          <a:blip xmlns:r="http://schemas.openxmlformats.org/officeDocument/2006/relationships" xmlns:a="http://schemas.openxmlformats.org/drawingml/2006/main" r:embed="R283689374ba543f0"/>
           <a:stretch xmlns:a="http://schemas.openxmlformats.org/drawingml/2006/main">
             <a:fillRect l="0" t="0" r="0" b="0"/>
           </a:stretch>
@@ -13456,7 +13456,7 @@
           <p:nvPr/>
         </p:nvPicPr>
         <p:blipFill>
-          <a:blip xmlns:r="http://schemas.openxmlformats.org/officeDocument/2006/relationships" xmlns:a="http://schemas.openxmlformats.org/drawingml/2006/main" r:embed="R48a98977a2ee4c0e"/>
+          <a:blip xmlns:r="http://schemas.openxmlformats.org/officeDocument/2006/relationships" xmlns:a="http://schemas.openxmlformats.org/drawingml/2006/main" r:embed="R6b8453bce61841bd"/>
           <a:stretch xmlns:a="http://schemas.openxmlformats.org/drawingml/2006/main">
             <a:fillRect l="0" t="0" r="0" b="0"/>
           </a:stretch>
@@ -13641,7 +13641,7 @@
           <p:nvPr/>
         </p:nvPicPr>
         <p:blipFill>
-          <a:blip xmlns:r="http://schemas.openxmlformats.org/officeDocument/2006/relationships" xmlns:a="http://schemas.openxmlformats.org/drawingml/2006/main" r:embed="R827635324c72463c"/>
+          <a:blip xmlns:r="http://schemas.openxmlformats.org/officeDocument/2006/relationships" xmlns:a="http://schemas.openxmlformats.org/drawingml/2006/main" r:embed="R12dd5a44779d4644"/>
           <a:stretch xmlns:a="http://schemas.openxmlformats.org/drawingml/2006/main">
             <a:fillRect l="0" t="0" r="0" b="0"/>
           </a:stretch>
@@ -13665,7 +13665,7 @@
           <p:nvPr/>
         </p:nvPicPr>
         <p:blipFill>
-          <a:blip xmlns:r="http://schemas.openxmlformats.org/officeDocument/2006/relationships" xmlns:a="http://schemas.openxmlformats.org/drawingml/2006/main" r:embed="R631ab3a5918143f8"/>
+          <a:blip xmlns:r="http://schemas.openxmlformats.org/officeDocument/2006/relationships" xmlns:a="http://schemas.openxmlformats.org/drawingml/2006/main" r:embed="R1002f213d8544701"/>
           <a:stretch xmlns:a="http://schemas.openxmlformats.org/drawingml/2006/main">
             <a:fillRect l="0" t="0" r="0" b="0"/>
           </a:stretch>
@@ -14594,7 +14594,7 @@
           <p:nvPr/>
         </p:nvPicPr>
         <p:blipFill>
-          <a:blip xmlns:r="http://schemas.openxmlformats.org/officeDocument/2006/relationships" xmlns:a="http://schemas.openxmlformats.org/drawingml/2006/main" r:embed="R68f9d33bf936459a"/>
+          <a:blip xmlns:r="http://schemas.openxmlformats.org/officeDocument/2006/relationships" xmlns:a="http://schemas.openxmlformats.org/drawingml/2006/main" r:embed="Rf60693b6824c409a"/>
           <a:stretch xmlns:a="http://schemas.openxmlformats.org/drawingml/2006/main">
             <a:fillRect l="0" t="0" r="0" b="0"/>
           </a:stretch>
@@ -14618,7 +14618,7 @@
           <p:nvPr/>
         </p:nvPicPr>
         <p:blipFill>
-          <a:blip xmlns:r="http://schemas.openxmlformats.org/officeDocument/2006/relationships" xmlns:a="http://schemas.openxmlformats.org/drawingml/2006/main" r:embed="R9edbd7bd84c64dcf"/>
+          <a:blip xmlns:r="http://schemas.openxmlformats.org/officeDocument/2006/relationships" xmlns:a="http://schemas.openxmlformats.org/drawingml/2006/main" r:embed="Rb1a2d329b7f3400c"/>
           <a:stretch xmlns:a="http://schemas.openxmlformats.org/drawingml/2006/main">
             <a:fillRect l="0" t="0" r="0" b="0"/>
           </a:stretch>
@@ -14858,7 +14858,7 @@
           <p:nvPr/>
         </p:nvPicPr>
         <p:blipFill>
-          <a:blip xmlns:r="http://schemas.openxmlformats.org/officeDocument/2006/relationships" xmlns:a="http://schemas.openxmlformats.org/drawingml/2006/main" r:embed="R6933fc2efe894b11"/>
+          <a:blip xmlns:r="http://schemas.openxmlformats.org/officeDocument/2006/relationships" xmlns:a="http://schemas.openxmlformats.org/drawingml/2006/main" r:embed="Rd63cd8e1f9d24c52"/>
           <a:stretch xmlns:a="http://schemas.openxmlformats.org/drawingml/2006/main">
             <a:fillRect l="0" t="0" r="0" b="0"/>
           </a:stretch>
@@ -14935,7 +14935,7 @@
           <p:nvPr/>
         </p:nvPicPr>
         <p:blipFill>
-          <a:blip xmlns:r="http://schemas.openxmlformats.org/officeDocument/2006/relationships" xmlns:a="http://schemas.openxmlformats.org/drawingml/2006/main" r:embed="Rcc55d118b7c04550"/>
+          <a:blip xmlns:r="http://schemas.openxmlformats.org/officeDocument/2006/relationships" xmlns:a="http://schemas.openxmlformats.org/drawingml/2006/main" r:embed="R7cdac669925d44d7"/>
           <a:stretch xmlns:a="http://schemas.openxmlformats.org/drawingml/2006/main">
             <a:fillRect l="0" t="0" r="0" b="0"/>
           </a:stretch>
@@ -15012,7 +15012,7 @@
           <p:nvPr/>
         </p:nvPicPr>
         <p:blipFill>
-          <a:blip xmlns:r="http://schemas.openxmlformats.org/officeDocument/2006/relationships" xmlns:a="http://schemas.openxmlformats.org/drawingml/2006/main" r:embed="Ra8a7ff6cc1c24afc"/>
+          <a:blip xmlns:r="http://schemas.openxmlformats.org/officeDocument/2006/relationships" xmlns:a="http://schemas.openxmlformats.org/drawingml/2006/main" r:embed="R8d86b1806ec24664"/>
           <a:stretch xmlns:a="http://schemas.openxmlformats.org/drawingml/2006/main">
             <a:fillRect l="0" t="0" r="0" b="0"/>
           </a:stretch>
@@ -15089,7 +15089,7 @@
           <p:nvPr/>
         </p:nvPicPr>
         <p:blipFill>
-          <a:blip xmlns:r="http://schemas.openxmlformats.org/officeDocument/2006/relationships" xmlns:a="http://schemas.openxmlformats.org/drawingml/2006/main" r:embed="R8c0f2b6e98194d5b"/>
+          <a:blip xmlns:r="http://schemas.openxmlformats.org/officeDocument/2006/relationships" xmlns:a="http://schemas.openxmlformats.org/drawingml/2006/main" r:embed="R7538d15473ec43bd"/>
           <a:stretch xmlns:a="http://schemas.openxmlformats.org/drawingml/2006/main">
             <a:fillRect l="0" t="0" r="0" b="0"/>
           </a:stretch>
@@ -15166,7 +15166,7 @@
           <p:nvPr/>
         </p:nvPicPr>
         <p:blipFill>
-          <a:blip xmlns:r="http://schemas.openxmlformats.org/officeDocument/2006/relationships" xmlns:a="http://schemas.openxmlformats.org/drawingml/2006/main" r:embed="R1e745627018e44d6"/>
+          <a:blip xmlns:r="http://schemas.openxmlformats.org/officeDocument/2006/relationships" xmlns:a="http://schemas.openxmlformats.org/drawingml/2006/main" r:embed="Ra2ca37f5cd884bff"/>
           <a:stretch xmlns:a="http://schemas.openxmlformats.org/drawingml/2006/main">
             <a:fillRect l="0" t="0" r="0" b="0"/>
           </a:stretch>
@@ -15243,7 +15243,7 @@
           <p:nvPr/>
         </p:nvPicPr>
         <p:blipFill>
-          <a:blip xmlns:r="http://schemas.openxmlformats.org/officeDocument/2006/relationships" xmlns:a="http://schemas.openxmlformats.org/drawingml/2006/main" r:embed="R63c0da2f84344f84"/>
+          <a:blip xmlns:r="http://schemas.openxmlformats.org/officeDocument/2006/relationships" xmlns:a="http://schemas.openxmlformats.org/drawingml/2006/main" r:embed="R531952fd7ec44476"/>
           <a:stretch xmlns:a="http://schemas.openxmlformats.org/drawingml/2006/main">
             <a:fillRect l="0" t="0" r="0" b="0"/>
           </a:stretch>
@@ -15320,7 +15320,7 @@
           <p:nvPr/>
         </p:nvPicPr>
         <p:blipFill>
-          <a:blip xmlns:r="http://schemas.openxmlformats.org/officeDocument/2006/relationships" xmlns:a="http://schemas.openxmlformats.org/drawingml/2006/main" r:embed="R06f2573431ac4d3d"/>
+          <a:blip xmlns:r="http://schemas.openxmlformats.org/officeDocument/2006/relationships" xmlns:a="http://schemas.openxmlformats.org/drawingml/2006/main" r:embed="Re8c74edb28c542cf"/>
           <a:stretch xmlns:a="http://schemas.openxmlformats.org/drawingml/2006/main">
             <a:fillRect l="0" t="0" r="0" b="0"/>
           </a:stretch>
@@ -15614,7 +15614,7 @@
           <p:nvPr/>
         </p:nvPicPr>
         <p:blipFill>
-          <a:blip xmlns:r="http://schemas.openxmlformats.org/officeDocument/2006/relationships" xmlns:a="http://schemas.openxmlformats.org/drawingml/2006/main" r:embed="R49d2ea0a29dd4cfa"/>
+          <a:blip xmlns:r="http://schemas.openxmlformats.org/officeDocument/2006/relationships" xmlns:a="http://schemas.openxmlformats.org/drawingml/2006/main" r:embed="R53e3140204f847fb"/>
           <a:stretch xmlns:a="http://schemas.openxmlformats.org/drawingml/2006/main">
             <a:fillRect l="0" t="0" r="0" b="0"/>
           </a:stretch>
@@ -15799,7 +15799,7 @@
           <p:nvPr/>
         </p:nvPicPr>
         <p:blipFill>
-          <a:blip xmlns:r="http://schemas.openxmlformats.org/officeDocument/2006/relationships" xmlns:a="http://schemas.openxmlformats.org/drawingml/2006/main" r:embed="Rd4eed1e5bb3c4d38"/>
+          <a:blip xmlns:r="http://schemas.openxmlformats.org/officeDocument/2006/relationships" xmlns:a="http://schemas.openxmlformats.org/drawingml/2006/main" r:embed="R62c53e2e34b146a0"/>
           <a:stretch xmlns:a="http://schemas.openxmlformats.org/drawingml/2006/main">
             <a:fillRect l="0" t="0" r="0" b="0"/>
           </a:stretch>
@@ -15823,7 +15823,7 @@
           <p:nvPr/>
         </p:nvPicPr>
         <p:blipFill>
-          <a:blip xmlns:r="http://schemas.openxmlformats.org/officeDocument/2006/relationships" xmlns:a="http://schemas.openxmlformats.org/drawingml/2006/main" r:embed="R2b32e528bec64ee7"/>
+          <a:blip xmlns:r="http://schemas.openxmlformats.org/officeDocument/2006/relationships" xmlns:a="http://schemas.openxmlformats.org/drawingml/2006/main" r:embed="R582035c0edeb4613"/>
           <a:stretch xmlns:a="http://schemas.openxmlformats.org/drawingml/2006/main">
             <a:fillRect l="0" t="0" r="0" b="0"/>
           </a:stretch>
@@ -16755,7 +16755,7 @@
           <p:nvPr/>
         </p:nvPicPr>
         <p:blipFill>
-          <a:blip xmlns:r="http://schemas.openxmlformats.org/officeDocument/2006/relationships" xmlns:a="http://schemas.openxmlformats.org/drawingml/2006/main" r:embed="Rec7873f1d453415f"/>
+          <a:blip xmlns:r="http://schemas.openxmlformats.org/officeDocument/2006/relationships" xmlns:a="http://schemas.openxmlformats.org/drawingml/2006/main" r:embed="R52b7cc48465541b0"/>
           <a:stretch xmlns:a="http://schemas.openxmlformats.org/drawingml/2006/main">
             <a:fillRect l="0" t="0" r="0" b="0"/>
           </a:stretch>
@@ -16779,7 +16779,7 @@
           <p:nvPr/>
         </p:nvPicPr>
         <p:blipFill>
-          <a:blip xmlns:r="http://schemas.openxmlformats.org/officeDocument/2006/relationships" xmlns:a="http://schemas.openxmlformats.org/drawingml/2006/main" r:embed="R754912beb4be421d"/>
+          <a:blip xmlns:r="http://schemas.openxmlformats.org/officeDocument/2006/relationships" xmlns:a="http://schemas.openxmlformats.org/drawingml/2006/main" r:embed="R8095aeb023ef46ad"/>
           <a:stretch xmlns:a="http://schemas.openxmlformats.org/drawingml/2006/main">
             <a:fillRect l="0" t="0" r="0" b="0"/>
           </a:stretch>
@@ -17019,7 +17019,7 @@
           <p:nvPr/>
         </p:nvPicPr>
         <p:blipFill>
-          <a:blip xmlns:r="http://schemas.openxmlformats.org/officeDocument/2006/relationships" xmlns:a="http://schemas.openxmlformats.org/drawingml/2006/main" r:embed="Rbd6dbde04bc34e86"/>
+          <a:blip xmlns:r="http://schemas.openxmlformats.org/officeDocument/2006/relationships" xmlns:a="http://schemas.openxmlformats.org/drawingml/2006/main" r:embed="R7066f6534b1c45cb"/>
           <a:stretch xmlns:a="http://schemas.openxmlformats.org/drawingml/2006/main">
             <a:fillRect l="0" t="0" r="0" b="0"/>
           </a:stretch>
@@ -17096,7 +17096,7 @@
           <p:nvPr/>
         </p:nvPicPr>
         <p:blipFill>
-          <a:blip xmlns:r="http://schemas.openxmlformats.org/officeDocument/2006/relationships" xmlns:a="http://schemas.openxmlformats.org/drawingml/2006/main" r:embed="Ra9305068f30e47e4"/>
+          <a:blip xmlns:r="http://schemas.openxmlformats.org/officeDocument/2006/relationships" xmlns:a="http://schemas.openxmlformats.org/drawingml/2006/main" r:embed="Rfc3c9f5a000e4457"/>
           <a:stretch xmlns:a="http://schemas.openxmlformats.org/drawingml/2006/main">
             <a:fillRect l="0" t="0" r="0" b="0"/>
           </a:stretch>
@@ -17173,7 +17173,7 @@
           <p:nvPr/>
         </p:nvPicPr>
         <p:blipFill>
-          <a:blip xmlns:r="http://schemas.openxmlformats.org/officeDocument/2006/relationships" xmlns:a="http://schemas.openxmlformats.org/drawingml/2006/main" r:embed="R9be93c3d12994e68"/>
+          <a:blip xmlns:r="http://schemas.openxmlformats.org/officeDocument/2006/relationships" xmlns:a="http://schemas.openxmlformats.org/drawingml/2006/main" r:embed="R1df103687b7e4a07"/>
           <a:stretch xmlns:a="http://schemas.openxmlformats.org/drawingml/2006/main">
             <a:fillRect l="0" t="0" r="0" b="0"/>
           </a:stretch>
@@ -17250,7 +17250,7 @@
           <p:nvPr/>
         </p:nvPicPr>
         <p:blipFill>
-          <a:blip xmlns:r="http://schemas.openxmlformats.org/officeDocument/2006/relationships" xmlns:a="http://schemas.openxmlformats.org/drawingml/2006/main" r:embed="R4919cfac1d9b4717"/>
+          <a:blip xmlns:r="http://schemas.openxmlformats.org/officeDocument/2006/relationships" xmlns:a="http://schemas.openxmlformats.org/drawingml/2006/main" r:embed="Rbbf1635d47ee45de"/>
           <a:stretch xmlns:a="http://schemas.openxmlformats.org/drawingml/2006/main">
             <a:fillRect l="0" t="0" r="0" b="0"/>
           </a:stretch>
@@ -17327,7 +17327,7 @@
           <p:nvPr/>
         </p:nvPicPr>
         <p:blipFill>
-          <a:blip xmlns:r="http://schemas.openxmlformats.org/officeDocument/2006/relationships" xmlns:a="http://schemas.openxmlformats.org/drawingml/2006/main" r:embed="R3826ff25b9e5454e"/>
+          <a:blip xmlns:r="http://schemas.openxmlformats.org/officeDocument/2006/relationships" xmlns:a="http://schemas.openxmlformats.org/drawingml/2006/main" r:embed="R9ddf4ac265574350"/>
           <a:stretch xmlns:a="http://schemas.openxmlformats.org/drawingml/2006/main">
             <a:fillRect l="0" t="0" r="0" b="0"/>
           </a:stretch>
@@ -17404,7 +17404,7 @@
           <p:nvPr/>
         </p:nvPicPr>
         <p:blipFill>
-          <a:blip xmlns:r="http://schemas.openxmlformats.org/officeDocument/2006/relationships" xmlns:a="http://schemas.openxmlformats.org/drawingml/2006/main" r:embed="R37c6441961304da8"/>
+          <a:blip xmlns:r="http://schemas.openxmlformats.org/officeDocument/2006/relationships" xmlns:a="http://schemas.openxmlformats.org/drawingml/2006/main" r:embed="Re0a973cf249b4421"/>
           <a:stretch xmlns:a="http://schemas.openxmlformats.org/drawingml/2006/main">
             <a:fillRect l="0" t="0" r="0" b="0"/>
           </a:stretch>
@@ -17481,7 +17481,7 @@
           <p:nvPr/>
         </p:nvPicPr>
         <p:blipFill>
-          <a:blip xmlns:r="http://schemas.openxmlformats.org/officeDocument/2006/relationships" xmlns:a="http://schemas.openxmlformats.org/drawingml/2006/main" r:embed="Rfa11835f05864b24"/>
+          <a:blip xmlns:r="http://schemas.openxmlformats.org/officeDocument/2006/relationships" xmlns:a="http://schemas.openxmlformats.org/drawingml/2006/main" r:embed="Rfce80807a8274f74"/>
           <a:stretch xmlns:a="http://schemas.openxmlformats.org/drawingml/2006/main">
             <a:fillRect l="0" t="0" r="0" b="0"/>
           </a:stretch>
@@ -17775,7 +17775,7 @@
           <p:nvPr/>
         </p:nvPicPr>
         <p:blipFill>
-          <a:blip xmlns:r="http://schemas.openxmlformats.org/officeDocument/2006/relationships" xmlns:a="http://schemas.openxmlformats.org/drawingml/2006/main" r:embed="Rd9879048e2994347"/>
+          <a:blip xmlns:r="http://schemas.openxmlformats.org/officeDocument/2006/relationships" xmlns:a="http://schemas.openxmlformats.org/drawingml/2006/main" r:embed="Rd19b3ccefab945fe"/>
           <a:stretch xmlns:a="http://schemas.openxmlformats.org/drawingml/2006/main">
             <a:fillRect l="0" t="0" r="0" b="0"/>
           </a:stretch>
@@ -17960,7 +17960,7 @@
           <p:nvPr/>
         </p:nvPicPr>
         <p:blipFill>
-          <a:blip xmlns:r="http://schemas.openxmlformats.org/officeDocument/2006/relationships" xmlns:a="http://schemas.openxmlformats.org/drawingml/2006/main" r:embed="R9f307d5bcb2948c6"/>
+          <a:blip xmlns:r="http://schemas.openxmlformats.org/officeDocument/2006/relationships" xmlns:a="http://schemas.openxmlformats.org/drawingml/2006/main" r:embed="Rb38c6bb3b5554c15"/>
           <a:stretch xmlns:a="http://schemas.openxmlformats.org/drawingml/2006/main">
             <a:fillRect l="0" t="0" r="0" b="0"/>
           </a:stretch>
@@ -17984,7 +17984,7 @@
           <p:nvPr/>
         </p:nvPicPr>
         <p:blipFill>
-          <a:blip xmlns:r="http://schemas.openxmlformats.org/officeDocument/2006/relationships" xmlns:a="http://schemas.openxmlformats.org/drawingml/2006/main" r:embed="R38f23f396622496a"/>
+          <a:blip xmlns:r="http://schemas.openxmlformats.org/officeDocument/2006/relationships" xmlns:a="http://schemas.openxmlformats.org/drawingml/2006/main" r:embed="R767fb0812cc0424b"/>
           <a:stretch xmlns:a="http://schemas.openxmlformats.org/drawingml/2006/main">
             <a:fillRect l="0" t="0" r="0" b="0"/>
           </a:stretch>

</xml_diff>